<commit_message>
docs: align presentation with HCI final guideline
Add target-user/needs slide (slide 3) and reframe slide 2 as
background. Problem statements rewritten in user-needs language.
Outline now maps each slide to the guideline items and specs the
mandatory 3-minute implementation+experiment video (YouTube).
</commit_message>
<xml_diff>
--- a/docs/presentation/MagicExamHall_Presentation_Skeleton.pptx
+++ b/docs/presentation/MagicExamHall_Presentation_Skeleton.pptx
@@ -12,9 +12,10 @@
     <p:sldId id="260" r:id="rId6"/>
     <p:sldId id="261" r:id="rId7"/>
     <p:sldId id="262" r:id="rId8"/>
+    <p:sldId id="263" r:id="rId9"/>
   </p:sldIdLst>
   <p:notesMasterIdLst>
-    <p:notesMasterId r:id="rId9"/>
+    <p:notesMasterId r:id="rId10"/>
   </p:notesMasterIdLst>
   <p:sldSz cx="9144000" cy="5143500"/>
   <p:notesSz cx="5143500" cy="9144000"/>
@@ -1078,6 +1079,94 @@
 </p:notes>
 </file>
 
+<file path=ppt/notesSlides/notesSlide8.xml><?xml version="1.0" encoding="utf-8"?>
+<p:notes xmlns:a="http://schemas.openxmlformats.org/drawingml/2006/main" xmlns:r="http://schemas.openxmlformats.org/officeDocument/2006/relationships" xmlns:p="http://schemas.openxmlformats.org/presentationml/2006/main">
+  <p:cSld>
+    <p:spTree>
+      <p:nvGrpSpPr>
+        <p:cNvPr id="1" name=""/>
+        <p:cNvGrpSpPr/>
+        <p:nvPr/>
+      </p:nvGrpSpPr>
+      <p:grpSpPr>
+        <a:xfrm>
+          <a:off x="0" y="0"/>
+          <a:ext cx="0" cy="0"/>
+          <a:chOff x="0" y="0"/>
+          <a:chExt cx="0" cy="0"/>
+        </a:xfrm>
+      </p:grpSpPr>
+      <p:sp>
+        <p:nvSpPr>
+          <p:cNvPr id="2" name="Slide Image Placeholder 1"/>
+          <p:cNvSpPr>
+            <a:spLocks noGrp="1" noRot="1" noChangeAspect="1"/>
+          </p:cNvSpPr>
+          <p:nvPr>
+            <p:ph type="sldImg"/>
+          </p:nvPr>
+        </p:nvSpPr>
+        <p:spPr/>
+      </p:sp>
+      <p:sp>
+        <p:nvSpPr>
+          <p:cNvPr id="3" name="Notes Placeholder 2"/>
+          <p:cNvSpPr>
+            <a:spLocks noGrp="1"/>
+          </p:cNvSpPr>
+          <p:nvPr>
+            <p:ph type="body" idx="1"/>
+          </p:nvPr>
+        </p:nvSpPr>
+        <p:spPr/>
+        <p:txBody>
+          <a:bodyPr/>
+          <a:lstStyle/>
+          <a:p>
+            <a:r>
+              <a:rPr lang="en-US" dirty="0"/>
+              <a:t/>
+            </a:r>
+            <a:endParaRPr lang="en-US" dirty="0"/>
+          </a:p>
+        </p:txBody>
+      </p:sp>
+      <p:sp>
+        <p:nvSpPr>
+          <p:cNvPr id="4" name="Slide Number Placeholder 3"/>
+          <p:cNvSpPr>
+            <a:spLocks noGrp="1"/>
+          </p:cNvSpPr>
+          <p:nvPr>
+            <p:ph type="sldNum" sz="quarter" idx="10"/>
+          </p:nvPr>
+        </p:nvSpPr>
+        <p:spPr/>
+        <p:txBody>
+          <a:bodyPr/>
+          <a:lstStyle/>
+          <a:p>
+            <a:fld id="{F7021451-1387-4CA6-816F-3879F97B5CBC}" type="slidenum">
+              <a:rPr lang="en-US"/>
+              <a:t>8</a:t>
+            </a:fld>
+            <a:endParaRPr lang="en-US"/>
+          </a:p>
+        </p:txBody>
+      </p:sp>
+    </p:spTree>
+    <p:extLst>
+      <p:ext uri="{BB962C8B-B14F-4D97-AF65-F5344CB8AC3E}">
+        <p14:creationId xmlns:p14="http://schemas.microsoft.com/office/powerpoint/2010/main" val="1024086991"/>
+      </p:ext>
+    </p:extLst>
+  </p:cSld>
+  <p:clrMapOvr>
+    <a:masterClrMapping/>
+  </p:clrMapOvr>
+</p:notes>
+</file>
+
 <file path=ppt/slideLayouts/slideLayout1.xml><?xml version="1.0" encoding="utf-8"?>
 <p:sldLayout xmlns:a="http://schemas.openxmlformats.org/drawingml/2006/main" xmlns:r="http://schemas.openxmlformats.org/officeDocument/2006/relationships" xmlns:p="http://schemas.openxmlformats.org/presentationml/2006/main" preserve="1">
   <p:cSld name="DEFAULT">
@@ -1824,7 +1913,7 @@
                 <a:ea typeface="Malgun Gothic" pitchFamily="34" charset="-122"/>
                 <a:cs typeface="Malgun Gothic" pitchFamily="34" charset="-120"/>
               </a:rPr>
-              <a:t>발표 5~8분  ·  시연 영상 2분 백업</a:t>
+              <a:t>발표 약 9분  ·  구현·실험 영상 3분 (YouTube)</a:t>
             </a:r>
             <a:endParaRPr lang="en-US" sz="1200" dirty="0"/>
           </a:p>
@@ -2017,7 +2106,7 @@
                 <a:ea typeface="Malgun Gothic" pitchFamily="34" charset="-122"/>
                 <a:cs typeface="Malgun Gothic" pitchFamily="34" charset="-120"/>
               </a:rPr>
-              <a:t>문제</a:t>
+              <a:t>배경</a:t>
             </a:r>
             <a:endParaRPr lang="en-US" sz="1200" dirty="0"/>
           </a:p>
@@ -2675,7 +2764,7 @@
                 <a:ea typeface="Malgun Gothic" pitchFamily="34" charset="-122"/>
                 <a:cs typeface="Malgun Gothic" pitchFamily="34" charset="-120"/>
               </a:rPr>
-              <a:t>연구 질문  </a:t>
+              <a:t>20년간 비어 있던 교차점  </a:t>
             </a:r>
             <a:pPr indent="0" marL="0">
               <a:buNone/>
@@ -2689,7 +2778,7 @@
                 <a:ea typeface="Malgun Gothic" pitchFamily="34" charset="-122"/>
                 <a:cs typeface="Malgun Gothic" pitchFamily="34" charset="-120"/>
               </a:rPr>
-              <a:t>기호 기반 입력이 재미와 몰입을 만들면서도, 실패 이유를 납득 가능하게 설명할 수 있는가? (GAME_DESIGN §1)</a:t>
+              <a:t>두 축을 가진 게임은 많지만, 셋(손으로 그리기 × 발견형 퍼즐 × 실패가 단서)을 다 가진 작품은 사실상 없다.</a:t>
             </a:r>
             <a:endParaRPr lang="en-US" sz="1300" dirty="0"/>
           </a:p>
@@ -2760,7 +2849,7 @@
                 <a:ea typeface="Malgun Gothic" pitchFamily="34" charset="-122"/>
                 <a:cs typeface="Malgun Gothic" pitchFamily="34" charset="-120"/>
               </a:rPr>
-              <a:t>설계</a:t>
+              <a:t>타깃 유저 · 니즈</a:t>
             </a:r>
             <a:endParaRPr lang="en-US" sz="1200" dirty="0"/>
           </a:p>
@@ -2799,7 +2888,7 @@
                 <a:ea typeface="Malgun Gothic" pitchFamily="34" charset="-122"/>
                 <a:cs typeface="Malgun Gothic" pitchFamily="34" charset="-120"/>
               </a:rPr>
-              <a:t>마법 문법 — 동사와 장식</a:t>
+              <a:t>누구의 어떤 문제를 푸는가</a:t>
             </a:r>
             <a:endParaRPr lang="en-US" sz="3000" dirty="0"/>
           </a:p>
@@ -2840,7 +2929,7 @@
                 <a:ea typeface="Malgun Gothic" pitchFamily="34" charset="-122"/>
                 <a:cs typeface="Malgun Gothic" pitchFamily="34" charset="-120"/>
               </a:rPr>
-              <a:t>1:30</a:t>
+              <a:t>1:00</a:t>
             </a:r>
             <a:endParaRPr lang="en-US" sz="1100" dirty="0"/>
           </a:p>
@@ -2855,7 +2944,7 @@
         <p:spPr>
           <a:xfrm>
             <a:off x="457200" y="1371600"/>
-            <a:ext cx="4023360" cy="2103120"/>
+            <a:ext cx="3749040" cy="2286000"/>
           </a:xfrm>
           <a:prstGeom prst="rect">
             <a:avLst/>
@@ -2880,7 +2969,7 @@
         <p:spPr>
           <a:xfrm>
             <a:off x="658368" y="1517904"/>
-            <a:ext cx="3657600" cy="274320"/>
+            <a:ext cx="3383280" cy="292608"/>
           </a:xfrm>
           <a:prstGeom prst="rect">
             <a:avLst/>
@@ -2896,7 +2985,49 @@
               <a:buNone/>
             </a:pPr>
             <a:r>
-              <a:rPr lang="en-US" sz="1300" b="1" dirty="0">
+              <a:rPr lang="en-US" sz="1350" b="1" dirty="0">
+                <a:solidFill>
+                  <a:srgbClr val="F0B450"/>
+                </a:solidFill>
+                <a:latin typeface="Malgun Gothic" pitchFamily="34" charset="0"/>
+                <a:ea typeface="Malgun Gothic" pitchFamily="34" charset="-122"/>
+                <a:cs typeface="Malgun Gothic" pitchFamily="34" charset="-120"/>
+              </a:rPr>
+              <a:t>타깃 유저</a:t>
+            </a:r>
+            <a:endParaRPr lang="en-US" sz="1350" dirty="0"/>
+          </a:p>
+        </p:txBody>
+      </p:sp>
+      <p:sp>
+        <p:nvSpPr>
+          <p:cNvPr id="7" name="Text 5"/>
+          <p:cNvSpPr/>
+          <p:nvPr/>
+        </p:nvSpPr>
+        <p:spPr>
+          <a:xfrm>
+            <a:off x="658368" y="1828800"/>
+            <a:ext cx="3383280" cy="1737360"/>
+          </a:xfrm>
+          <a:prstGeom prst="rect">
+            <a:avLst/>
+          </a:prstGeom>
+          <a:noFill/>
+          <a:ln/>
+        </p:spPr>
+        <p:txBody>
+          <a:bodyPr wrap="square" lIns="0" tIns="0" rIns="0" bIns="0" rtlCol="0" anchor="ctr"/>
+          <a:lstStyle/>
+          <a:p>
+            <a:pPr indent="0" marL="0">
+              <a:spcAft>
+                <a:spcPts val="500"/>
+              </a:spcAft>
+              <a:buNone/>
+            </a:pPr>
+            <a:r>
+              <a:rPr lang="en-US" sz="1200" b="1" dirty="0">
                 <a:solidFill>
                   <a:srgbClr val="F2EEFA"/>
                 </a:solidFill>
@@ -2904,343 +3035,49 @@
                 <a:ea typeface="Malgun Gothic" pitchFamily="34" charset="-122"/>
                 <a:cs typeface="Malgun Gothic" pitchFamily="34" charset="-120"/>
               </a:rPr>
-              <a:t>base 5종 — 세계를 바꾸는 동사</a:t>
-            </a:r>
-            <a:endParaRPr lang="en-US" sz="1300" dirty="0"/>
-          </a:p>
-        </p:txBody>
-      </p:sp>
-      <p:sp>
-        <p:nvSpPr>
-          <p:cNvPr id="7" name="Shape 5"/>
-          <p:cNvSpPr/>
-          <p:nvPr/>
-        </p:nvSpPr>
-        <p:spPr>
-          <a:xfrm>
-            <a:off x="658368" y="1828800"/>
-            <a:ext cx="566928" cy="566928"/>
-          </a:xfrm>
-          <a:prstGeom prst="ellipse">
-            <a:avLst/>
-          </a:prstGeom>
-          <a:ln w="19050">
-            <a:solidFill>
-              <a:srgbClr val="F0B450"/>
-            </a:solidFill>
-            <a:prstDash val="solid"/>
-          </a:ln>
-        </p:spPr>
-      </p:sp>
-      <p:sp>
-        <p:nvSpPr>
-          <p:cNvPr id="8" name="Text 6"/>
-          <p:cNvSpPr/>
-          <p:nvPr/>
-        </p:nvSpPr>
-        <p:spPr>
-          <a:xfrm>
-            <a:off x="658368" y="1828800"/>
-            <a:ext cx="566928" cy="566928"/>
-          </a:xfrm>
-          <a:prstGeom prst="rect">
-            <a:avLst/>
-          </a:prstGeom>
-          <a:noFill/>
-          <a:ln/>
-        </p:spPr>
-        <p:txBody>
-          <a:bodyPr wrap="square" rtlCol="0" anchor="ctr"/>
-          <a:lstStyle/>
-          <a:p>
-            <a:pPr algn="ctr" indent="0" marL="0">
-              <a:buNone/>
-            </a:pPr>
-            <a:r>
-              <a:rPr lang="en-US" sz="1100" dirty="0">
-                <a:solidFill>
-                  <a:srgbClr val="F0B450"/>
-                </a:solidFill>
-                <a:latin typeface="Malgun Gothic" pitchFamily="34" charset="0"/>
-                <a:ea typeface="Malgun Gothic" pitchFamily="34" charset="-122"/>
-                <a:cs typeface="Malgun Gothic" pitchFamily="34" charset="-120"/>
-              </a:rPr>
-              <a:t>불</a:t>
-            </a:r>
-            <a:endParaRPr lang="en-US" sz="1100" dirty="0"/>
-          </a:p>
-        </p:txBody>
-      </p:sp>
-      <p:sp>
-        <p:nvSpPr>
-          <p:cNvPr id="9" name="Shape 7"/>
-          <p:cNvSpPr/>
-          <p:nvPr/>
-        </p:nvSpPr>
-        <p:spPr>
-          <a:xfrm>
-            <a:off x="1371600" y="1828800"/>
-            <a:ext cx="566928" cy="566928"/>
-          </a:xfrm>
-          <a:prstGeom prst="ellipse">
-            <a:avLst/>
-          </a:prstGeom>
-          <a:ln w="19050">
-            <a:solidFill>
-              <a:srgbClr val="F0B450"/>
-            </a:solidFill>
-            <a:prstDash val="solid"/>
-          </a:ln>
-        </p:spPr>
-      </p:sp>
-      <p:sp>
-        <p:nvSpPr>
-          <p:cNvPr id="10" name="Text 8"/>
-          <p:cNvSpPr/>
-          <p:nvPr/>
-        </p:nvSpPr>
-        <p:spPr>
-          <a:xfrm>
-            <a:off x="1371600" y="1828800"/>
-            <a:ext cx="566928" cy="566928"/>
-          </a:xfrm>
-          <a:prstGeom prst="rect">
-            <a:avLst/>
-          </a:prstGeom>
-          <a:noFill/>
-          <a:ln/>
-        </p:spPr>
-        <p:txBody>
-          <a:bodyPr wrap="square" rtlCol="0" anchor="ctr"/>
-          <a:lstStyle/>
-          <a:p>
-            <a:pPr algn="ctr" indent="0" marL="0">
-              <a:buNone/>
-            </a:pPr>
-            <a:r>
-              <a:rPr lang="en-US" sz="1100" dirty="0">
-                <a:solidFill>
-                  <a:srgbClr val="F0B450"/>
-                </a:solidFill>
-                <a:latin typeface="Malgun Gothic" pitchFamily="34" charset="0"/>
-                <a:ea typeface="Malgun Gothic" pitchFamily="34" charset="-122"/>
-                <a:cs typeface="Malgun Gothic" pitchFamily="34" charset="-120"/>
-              </a:rPr>
-              <a:t>물</a:t>
-            </a:r>
-            <a:endParaRPr lang="en-US" sz="1100" dirty="0"/>
-          </a:p>
-        </p:txBody>
-      </p:sp>
-      <p:sp>
-        <p:nvSpPr>
-          <p:cNvPr id="11" name="Shape 9"/>
-          <p:cNvSpPr/>
-          <p:nvPr/>
-        </p:nvSpPr>
-        <p:spPr>
-          <a:xfrm>
-            <a:off x="2084832" y="1828800"/>
-            <a:ext cx="566928" cy="566928"/>
-          </a:xfrm>
-          <a:prstGeom prst="ellipse">
-            <a:avLst/>
-          </a:prstGeom>
-          <a:ln w="19050">
-            <a:solidFill>
-              <a:srgbClr val="F0B450"/>
-            </a:solidFill>
-            <a:prstDash val="solid"/>
-          </a:ln>
-        </p:spPr>
-      </p:sp>
-      <p:sp>
-        <p:nvSpPr>
-          <p:cNvPr id="12" name="Text 10"/>
-          <p:cNvSpPr/>
-          <p:nvPr/>
-        </p:nvSpPr>
-        <p:spPr>
-          <a:xfrm>
-            <a:off x="2084832" y="1828800"/>
-            <a:ext cx="566928" cy="566928"/>
-          </a:xfrm>
-          <a:prstGeom prst="rect">
-            <a:avLst/>
-          </a:prstGeom>
-          <a:noFill/>
-          <a:ln/>
-        </p:spPr>
-        <p:txBody>
-          <a:bodyPr wrap="square" rtlCol="0" anchor="ctr"/>
-          <a:lstStyle/>
-          <a:p>
-            <a:pPr algn="ctr" indent="0" marL="0">
-              <a:buNone/>
-            </a:pPr>
-            <a:r>
-              <a:rPr lang="en-US" sz="1100" dirty="0">
-                <a:solidFill>
-                  <a:srgbClr val="F0B450"/>
-                </a:solidFill>
-                <a:latin typeface="Malgun Gothic" pitchFamily="34" charset="0"/>
-                <a:ea typeface="Malgun Gothic" pitchFamily="34" charset="-122"/>
-                <a:cs typeface="Malgun Gothic" pitchFamily="34" charset="-120"/>
-              </a:rPr>
-              <a:t>바람</a:t>
-            </a:r>
-            <a:endParaRPr lang="en-US" sz="1100" dirty="0"/>
-          </a:p>
-        </p:txBody>
-      </p:sp>
-      <p:sp>
-        <p:nvSpPr>
-          <p:cNvPr id="13" name="Shape 11"/>
-          <p:cNvSpPr/>
-          <p:nvPr/>
-        </p:nvSpPr>
-        <p:spPr>
-          <a:xfrm>
-            <a:off x="2798064" y="1828800"/>
-            <a:ext cx="566928" cy="566928"/>
-          </a:xfrm>
-          <a:prstGeom prst="ellipse">
-            <a:avLst/>
-          </a:prstGeom>
-          <a:ln w="19050">
-            <a:solidFill>
-              <a:srgbClr val="F0B450"/>
-            </a:solidFill>
-            <a:prstDash val="solid"/>
-          </a:ln>
-        </p:spPr>
-      </p:sp>
-      <p:sp>
-        <p:nvSpPr>
-          <p:cNvPr id="14" name="Text 12"/>
-          <p:cNvSpPr/>
-          <p:nvPr/>
-        </p:nvSpPr>
-        <p:spPr>
-          <a:xfrm>
-            <a:off x="2798064" y="1828800"/>
-            <a:ext cx="566928" cy="566928"/>
-          </a:xfrm>
-          <a:prstGeom prst="rect">
-            <a:avLst/>
-          </a:prstGeom>
-          <a:noFill/>
-          <a:ln/>
-        </p:spPr>
-        <p:txBody>
-          <a:bodyPr wrap="square" rtlCol="0" anchor="ctr"/>
-          <a:lstStyle/>
-          <a:p>
-            <a:pPr algn="ctr" indent="0" marL="0">
-              <a:buNone/>
-            </a:pPr>
-            <a:r>
-              <a:rPr lang="en-US" sz="1100" dirty="0">
-                <a:solidFill>
-                  <a:srgbClr val="F0B450"/>
-                </a:solidFill>
-                <a:latin typeface="Malgun Gothic" pitchFamily="34" charset="0"/>
-                <a:ea typeface="Malgun Gothic" pitchFamily="34" charset="-122"/>
-                <a:cs typeface="Malgun Gothic" pitchFamily="34" charset="-120"/>
-              </a:rPr>
-              <a:t>땅</a:t>
-            </a:r>
-            <a:endParaRPr lang="en-US" sz="1100" dirty="0"/>
-          </a:p>
-        </p:txBody>
-      </p:sp>
-      <p:sp>
-        <p:nvSpPr>
-          <p:cNvPr id="15" name="Shape 13"/>
-          <p:cNvSpPr/>
-          <p:nvPr/>
-        </p:nvSpPr>
-        <p:spPr>
-          <a:xfrm>
-            <a:off x="3511296" y="1828800"/>
-            <a:ext cx="566928" cy="566928"/>
-          </a:xfrm>
-          <a:prstGeom prst="ellipse">
-            <a:avLst/>
-          </a:prstGeom>
-          <a:ln w="19050">
-            <a:solidFill>
-              <a:srgbClr val="F0B450"/>
-            </a:solidFill>
-            <a:prstDash val="solid"/>
-          </a:ln>
-        </p:spPr>
-      </p:sp>
-      <p:sp>
-        <p:nvSpPr>
-          <p:cNvPr id="16" name="Text 14"/>
-          <p:cNvSpPr/>
-          <p:nvPr/>
-        </p:nvSpPr>
-        <p:spPr>
-          <a:xfrm>
-            <a:off x="3511296" y="1828800"/>
-            <a:ext cx="566928" cy="566928"/>
-          </a:xfrm>
-          <a:prstGeom prst="rect">
-            <a:avLst/>
-          </a:prstGeom>
-          <a:noFill/>
-          <a:ln/>
-        </p:spPr>
-        <p:txBody>
-          <a:bodyPr wrap="square" rtlCol="0" anchor="ctr"/>
-          <a:lstStyle/>
-          <a:p>
-            <a:pPr algn="ctr" indent="0" marL="0">
-              <a:buNone/>
-            </a:pPr>
-            <a:r>
-              <a:rPr lang="en-US" sz="1100" dirty="0">
-                <a:solidFill>
-                  <a:srgbClr val="F0B450"/>
-                </a:solidFill>
-                <a:latin typeface="Malgun Gothic" pitchFamily="34" charset="0"/>
-                <a:ea typeface="Malgun Gothic" pitchFamily="34" charset="-122"/>
-                <a:cs typeface="Malgun Gothic" pitchFamily="34" charset="-120"/>
-              </a:rPr>
-              <a:t>생명</a:t>
-            </a:r>
-            <a:endParaRPr lang="en-US" sz="1100" dirty="0"/>
-          </a:p>
-        </p:txBody>
-      </p:sp>
-      <p:sp>
-        <p:nvSpPr>
-          <p:cNvPr id="17" name="Text 15"/>
-          <p:cNvSpPr/>
-          <p:nvPr/>
-        </p:nvSpPr>
-        <p:spPr>
-          <a:xfrm>
-            <a:off x="658368" y="2542032"/>
-            <a:ext cx="3657600" cy="274320"/>
-          </a:xfrm>
-          <a:prstGeom prst="rect">
-            <a:avLst/>
-          </a:prstGeom>
-          <a:noFill/>
-          <a:ln/>
-        </p:spPr>
-        <p:txBody>
-          <a:bodyPr wrap="square" lIns="0" tIns="0" rIns="0" bIns="0" rtlCol="0" anchor="ctr"/>
-          <a:lstStyle/>
-          <a:p>
-            <a:pPr indent="0" marL="0">
-              <a:buNone/>
-            </a:pPr>
-            <a:r>
-              <a:rPr lang="en-US" sz="1300" b="1" dirty="0">
+              <a:t>공략 없이 스스로 발견하는 과정을 즐기는 PC 퍼즐·어드벤처 게이머</a:t>
+            </a:r>
+            <a:endParaRPr lang="en-US" sz="1200" dirty="0"/>
+          </a:p>
+          <a:p>
+            <a:pPr indent="0" marL="0">
+              <a:spcAft>
+                <a:spcPts val="500"/>
+              </a:spcAft>
+              <a:buNone/>
+            </a:pPr>
+            <a:r>
+              <a:rPr lang="en-US" sz="1200" dirty="0">
+                <a:solidFill>
+                  <a:srgbClr val="9A92B8"/>
+                </a:solidFill>
+                <a:latin typeface="Malgun Gothic" pitchFamily="34" charset="0"/>
+                <a:ea typeface="Malgun Gothic" pitchFamily="34" charset="-122"/>
+                <a:cs typeface="Malgun Gothic" pitchFamily="34" charset="-120"/>
+              </a:rPr>
+              <a:t>(The Witness, Outer Wilds 류 선호층)</a:t>
+            </a:r>
+            <a:endParaRPr lang="en-US" sz="1200" dirty="0"/>
+          </a:p>
+          <a:p>
+            <a:pPr indent="0" marL="0">
+              <a:spcAft>
+                <a:spcPts val="500"/>
+              </a:spcAft>
+              <a:buNone/>
+            </a:pPr>
+            <a:endParaRPr lang="en-US" sz="1200" dirty="0"/>
+          </a:p>
+          <a:p>
+            <a:pPr marL="342900" indent="-342900">
+              <a:spcAft>
+                <a:spcPts val="500"/>
+              </a:spcAft>
+              <a:buSzPct val="100000"/>
+              <a:buChar char="•"/>
+            </a:pPr>
+            <a:r>
+              <a:rPr lang="en-US" sz="1200" dirty="0">
                 <a:solidFill>
                   <a:srgbClr val="F2EEFA"/>
                 </a:solidFill>
@@ -3248,61 +3085,64 @@
                 <a:ea typeface="Malgun Gothic" pitchFamily="34" charset="-122"/>
                 <a:cs typeface="Malgun Gothic" pitchFamily="34" charset="-120"/>
               </a:rPr>
-              <a:t>overlay 6종 — 동사를 바꾸는 장식</a:t>
-            </a:r>
-            <a:endParaRPr lang="en-US" sz="1300" dirty="0"/>
-          </a:p>
-        </p:txBody>
-      </p:sp>
-      <p:sp>
-        <p:nvSpPr>
-          <p:cNvPr id="18" name="Text 16"/>
-          <p:cNvSpPr/>
-          <p:nvPr/>
-        </p:nvSpPr>
-        <p:spPr>
-          <a:xfrm>
-            <a:off x="658368" y="2816352"/>
-            <a:ext cx="3657600" cy="548640"/>
-          </a:xfrm>
-          <a:prstGeom prst="rect">
-            <a:avLst/>
-          </a:prstGeom>
-          <a:noFill/>
-          <a:ln/>
-        </p:spPr>
-        <p:txBody>
-          <a:bodyPr wrap="square" lIns="0" tIns="0" rIns="0" bIns="0" rtlCol="0" anchor="ctr"/>
-          <a:lstStyle/>
-          <a:p>
-            <a:pPr indent="0" marL="0">
-              <a:buNone/>
-            </a:pPr>
-            <a:r>
-              <a:rPr lang="en-US" sz="1150" dirty="0">
-                <a:solidFill>
-                  <a:srgbClr val="9D7BE8"/>
-                </a:solidFill>
-                <a:latin typeface="Malgun Gothic" pitchFamily="34" charset="0"/>
-                <a:ea typeface="Malgun Gothic" pitchFamily="34" charset="-122"/>
-                <a:cs typeface="Malgun Gothic" pitchFamily="34" charset="-120"/>
-              </a:rPr>
-              <a:t>ice_bar · steel_brace · soul_dot · electric_fork · void_cut → martial_axis (의존성: void_cut 이후에만)</a:t>
-            </a:r>
-            <a:endParaRPr lang="en-US" sz="1150" dirty="0"/>
-          </a:p>
-        </p:txBody>
-      </p:sp>
-      <p:sp>
-        <p:nvSpPr>
-          <p:cNvPr id="19" name="Shape 17"/>
-          <p:cNvSpPr/>
-          <p:nvPr/>
-        </p:nvSpPr>
-        <p:spPr>
-          <a:xfrm>
-            <a:off x="4663440" y="1371600"/>
-            <a:ext cx="4151376" cy="2103120"/>
+              <a:t>마우스·키보드만 사용, 드로잉 입력 경험 불필요</a:t>
+            </a:r>
+            <a:endParaRPr lang="en-US" sz="1200" dirty="0"/>
+          </a:p>
+          <a:p>
+            <a:pPr marL="342900" indent="-342900">
+              <a:spcAft>
+                <a:spcPts val="500"/>
+              </a:spcAft>
+              <a:buSzPct val="100000"/>
+              <a:buChar char="•"/>
+            </a:pPr>
+            <a:r>
+              <a:rPr lang="en-US" sz="1200" dirty="0">
+                <a:solidFill>
+                  <a:srgbClr val="F2EEFA"/>
+                </a:solidFill>
+                <a:latin typeface="Malgun Gothic" pitchFamily="34" charset="0"/>
+                <a:ea typeface="Malgun Gothic" pitchFamily="34" charset="-122"/>
+                <a:cs typeface="Malgun Gothic" pitchFamily="34" charset="-120"/>
+              </a:rPr>
+              <a:t>1회차 30~60분의 짧은 완결 경험</a:t>
+            </a:r>
+            <a:endParaRPr lang="en-US" sz="1200" dirty="0"/>
+          </a:p>
+          <a:p>
+            <a:pPr marL="342900" indent="-342900">
+              <a:spcAft>
+                <a:spcPts val="500"/>
+              </a:spcAft>
+              <a:buSzPct val="100000"/>
+              <a:buChar char="•"/>
+            </a:pPr>
+            <a:r>
+              <a:rPr lang="en-US" sz="1200" dirty="0">
+                <a:solidFill>
+                  <a:srgbClr val="F2EEFA"/>
+                </a:solidFill>
+                <a:latin typeface="Malgun Gothic" pitchFamily="34" charset="0"/>
+                <a:ea typeface="Malgun Gothic" pitchFamily="34" charset="-122"/>
+                <a:cs typeface="Malgun Gothic" pitchFamily="34" charset="-120"/>
+              </a:rPr>
+              <a:t>사람마다 필체가 달라 같은 도형도 다르게 그린다</a:t>
+            </a:r>
+            <a:endParaRPr lang="en-US" sz="1200" dirty="0"/>
+          </a:p>
+        </p:txBody>
+      </p:sp>
+      <p:sp>
+        <p:nvSpPr>
+          <p:cNvPr id="8" name="Shape 6"/>
+          <p:cNvSpPr/>
+          <p:nvPr/>
+        </p:nvSpPr>
+        <p:spPr>
+          <a:xfrm>
+            <a:off x="4389120" y="1371600"/>
+            <a:ext cx="4425696" cy="2286000"/>
           </a:xfrm>
           <a:prstGeom prst="rect">
             <a:avLst/>
@@ -3320,14 +3160,14 @@
       </p:sp>
       <p:sp>
         <p:nvSpPr>
-          <p:cNvPr id="20" name="Text 18"/>
-          <p:cNvSpPr/>
-          <p:nvPr/>
-        </p:nvSpPr>
-        <p:spPr>
-          <a:xfrm>
-            <a:off x="4864608" y="1517904"/>
-            <a:ext cx="3749040" cy="274320"/>
+          <p:cNvPr id="9" name="Text 7"/>
+          <p:cNvSpPr/>
+          <p:nvPr/>
+        </p:nvSpPr>
+        <p:spPr>
+          <a:xfrm>
+            <a:off x="4590288" y="1517904"/>
+            <a:ext cx="4023360" cy="292608"/>
           </a:xfrm>
           <a:prstGeom prst="rect">
             <a:avLst/>
@@ -3343,7 +3183,49 @@
               <a:buNone/>
             </a:pPr>
             <a:r>
-              <a:rPr lang="en-US" sz="1300" b="1" dirty="0">
+              <a:rPr lang="en-US" sz="1350" b="1" dirty="0">
+                <a:solidFill>
+                  <a:srgbClr val="9D7BE8"/>
+                </a:solidFill>
+                <a:latin typeface="Malgun Gothic" pitchFamily="34" charset="0"/>
+                <a:ea typeface="Malgun Gothic" pitchFamily="34" charset="-122"/>
+                <a:cs typeface="Malgun Gothic" pitchFamily="34" charset="-120"/>
+              </a:rPr>
+              <a:t>니즈와 문제</a:t>
+            </a:r>
+            <a:endParaRPr lang="en-US" sz="1350" dirty="0"/>
+          </a:p>
+        </p:txBody>
+      </p:sp>
+      <p:sp>
+        <p:nvSpPr>
+          <p:cNvPr id="10" name="Text 8"/>
+          <p:cNvSpPr/>
+          <p:nvPr/>
+        </p:nvSpPr>
+        <p:spPr>
+          <a:xfrm>
+            <a:off x="4590288" y="1828800"/>
+            <a:ext cx="4023360" cy="1737360"/>
+          </a:xfrm>
+          <a:prstGeom prst="rect">
+            <a:avLst/>
+          </a:prstGeom>
+          <a:noFill/>
+          <a:ln/>
+        </p:spPr>
+        <p:txBody>
+          <a:bodyPr wrap="square" lIns="0" tIns="0" rIns="0" bIns="0" rtlCol="0" anchor="ctr"/>
+          <a:lstStyle/>
+          <a:p>
+            <a:pPr indent="0" marL="0">
+              <a:spcAft>
+                <a:spcPts val="400"/>
+              </a:spcAft>
+              <a:buNone/>
+            </a:pPr>
+            <a:r>
+              <a:rPr lang="en-US" sz="1150" b="1" dirty="0">
                 <a:solidFill>
                   <a:srgbClr val="F2EEFA"/>
                 </a:solidFill>
@@ -3351,58 +3233,39 @@
                 <a:ea typeface="Malgun Gothic" pitchFamily="34" charset="-122"/>
                 <a:cs typeface="Malgun Gothic" pitchFamily="34" charset="-120"/>
               </a:rPr>
-              <a:t>형태가 종류를, 품질이 세기를</a:t>
-            </a:r>
-            <a:endParaRPr lang="en-US" sz="1300" dirty="0"/>
-          </a:p>
-        </p:txBody>
-      </p:sp>
-      <p:sp>
-        <p:nvSpPr>
-          <p:cNvPr id="21" name="Text 19"/>
-          <p:cNvSpPr/>
-          <p:nvPr/>
-        </p:nvSpPr>
-        <p:spPr>
-          <a:xfrm>
-            <a:off x="4864608" y="1828800"/>
-            <a:ext cx="3749040" cy="1463040"/>
-          </a:xfrm>
-          <a:prstGeom prst="rect">
-            <a:avLst/>
-          </a:prstGeom>
-          <a:noFill/>
-          <a:ln/>
-        </p:spPr>
-        <p:txBody>
-          <a:bodyPr wrap="square" lIns="0" tIns="0" rIns="0" bIns="0" rtlCol="0" anchor="ctr"/>
-          <a:lstStyle/>
+              <a:t>① 제스처 입력은 실패 이유를 알려주지 않는다</a:t>
+            </a:r>
+            <a:endParaRPr lang="en-US" sz="1150" dirty="0"/>
+          </a:p>
           <a:p>
             <a:pPr indent="0" marL="0">
               <a:spcAft>
-                <a:spcPts val="600"/>
+                <a:spcPts val="400"/>
               </a:spcAft>
               <a:buNone/>
             </a:pPr>
             <a:r>
-              <a:rPr lang="en-US" sz="1250" b="1" dirty="0">
-                <a:solidFill>
-                  <a:srgbClr val="F0B450"/>
-                </a:solidFill>
-                <a:latin typeface="Malgun Gothic" pitchFamily="34" charset="0"/>
-                <a:ea typeface="Malgun Gothic" pitchFamily="34" charset="-122"/>
-                <a:cs typeface="Malgun Gothic" pitchFamily="34" charset="-120"/>
-              </a:rPr>
-              <a:t>family </a:t>
-            </a:r>
+              <a:rPr lang="en-US" sz="1150" dirty="0">
+                <a:solidFill>
+                  <a:srgbClr val="9A92B8"/>
+                </a:solidFill>
+                <a:latin typeface="Malgun Gothic" pitchFamily="34" charset="0"/>
+                <a:ea typeface="Malgun Gothic" pitchFamily="34" charset="-122"/>
+                <a:cs typeface="Malgun Gothic" pitchFamily="34" charset="-120"/>
+              </a:rPr>
+              <a:t>왜 거부됐는지 모르면 좌절하고 이탈한다</a:t>
+            </a:r>
+            <a:endParaRPr lang="en-US" sz="1150" dirty="0"/>
+          </a:p>
+          <a:p>
             <a:pPr indent="0" marL="0">
               <a:spcAft>
-                <a:spcPts val="600"/>
+                <a:spcPts val="400"/>
               </a:spcAft>
               <a:buNone/>
             </a:pPr>
             <a:r>
-              <a:rPr lang="en-US" sz="1250" dirty="0">
+              <a:rPr lang="en-US" sz="1150" b="1" dirty="0">
                 <a:solidFill>
                   <a:srgbClr val="F2EEFA"/>
                 </a:solidFill>
@@ -3410,33 +3273,39 @@
                 <a:ea typeface="Malgun Gothic" pitchFamily="34" charset="-122"/>
                 <a:cs typeface="Malgun Gothic" pitchFamily="34" charset="-120"/>
               </a:rPr>
-              <a:t>(무엇이 되는가)와 </a:t>
-            </a:r>
+              <a:t>② 하나의 '정답 모양'은 필체 다양성을 거부한다</a:t>
+            </a:r>
+            <a:endParaRPr lang="en-US" sz="1150" dirty="0"/>
+          </a:p>
+          <a:p>
             <a:pPr indent="0" marL="0">
               <a:spcAft>
-                <a:spcPts val="600"/>
+                <a:spcPts val="400"/>
               </a:spcAft>
               <a:buNone/>
             </a:pPr>
             <a:r>
-              <a:rPr lang="en-US" sz="1250" b="1" dirty="0">
-                <a:solidFill>
-                  <a:srgbClr val="F0B450"/>
-                </a:solidFill>
-                <a:latin typeface="Malgun Gothic" pitchFamily="34" charset="0"/>
-                <a:ea typeface="Malgun Gothic" pitchFamily="34" charset="-122"/>
-                <a:cs typeface="Malgun Gothic" pitchFamily="34" charset="-120"/>
-              </a:rPr>
-              <a:t>quality</a:t>
-            </a:r>
+              <a:rPr lang="en-US" sz="1150" dirty="0">
+                <a:solidFill>
+                  <a:srgbClr val="9A92B8"/>
+                </a:solidFill>
+                <a:latin typeface="Malgun Gothic" pitchFamily="34" charset="0"/>
+                <a:ea typeface="Malgun Gothic" pitchFamily="34" charset="-122"/>
+                <a:cs typeface="Malgun Gothic" pitchFamily="34" charset="-120"/>
+              </a:rPr>
+              <a:t>같은 도형도 사람마다 다르게 그린다 — 인식기가 흡수해야 한다</a:t>
+            </a:r>
+            <a:endParaRPr lang="en-US" sz="1150" dirty="0"/>
+          </a:p>
+          <a:p>
             <a:pPr indent="0" marL="0">
               <a:spcAft>
-                <a:spcPts val="600"/>
+                <a:spcPts val="400"/>
               </a:spcAft>
               <a:buNone/>
             </a:pPr>
             <a:r>
-              <a:rPr lang="en-US" sz="1250" dirty="0">
+              <a:rPr lang="en-US" sz="1150" b="1" dirty="0">
                 <a:solidFill>
                   <a:srgbClr val="F2EEFA"/>
                 </a:solidFill>
@@ -3444,39 +3313,19 @@
                 <a:ea typeface="Malgun Gothic" pitchFamily="34" charset="-122"/>
                 <a:cs typeface="Malgun Gothic" pitchFamily="34" charset="-120"/>
               </a:rPr>
-              <a:t> (얼마나 강한가)의 분리</a:t>
-            </a:r>
-            <a:endParaRPr lang="en-US" sz="1250" dirty="0"/>
+              <a:t>③ 정답 암기는 발견의 재미를 죽인다</a:t>
+            </a:r>
+            <a:endParaRPr lang="en-US" sz="1150" dirty="0"/>
           </a:p>
           <a:p>
             <a:pPr indent="0" marL="0">
               <a:spcAft>
-                <a:spcPts val="600"/>
+                <a:spcPts val="400"/>
               </a:spcAft>
               <a:buNone/>
             </a:pPr>
             <a:r>
-              <a:rPr lang="en-US" sz="1250" b="1" dirty="0">
-                <a:solidFill>
-                  <a:srgbClr val="F2EEFA"/>
-                </a:solidFill>
-                <a:latin typeface="Malgun Gothic" pitchFamily="34" charset="0"/>
-                <a:ea typeface="Malgun Gothic" pitchFamily="34" charset="-122"/>
-                <a:cs typeface="Malgun Gothic" pitchFamily="34" charset="-120"/>
-              </a:rPr>
-              <a:t>실패 처리: 단계적 힌트 escalator</a:t>
-            </a:r>
-            <a:endParaRPr lang="en-US" sz="1250" dirty="0"/>
-          </a:p>
-          <a:p>
-            <a:pPr indent="0" marL="0">
-              <a:spcAft>
-                <a:spcPts val="600"/>
-              </a:spcAft>
-              <a:buNone/>
-            </a:pPr>
-            <a:r>
-              <a:rPr lang="en-US" sz="1250" dirty="0">
+              <a:rPr lang="en-US" sz="1150" dirty="0">
                 <a:solidFill>
                   <a:srgbClr val="9A92B8"/>
                 </a:solidFill>
@@ -3484,22 +3333,22 @@
                 <a:ea typeface="Malgun Gothic" pitchFamily="34" charset="-122"/>
                 <a:cs typeface="Malgun Gothic" pitchFamily="34" charset="-120"/>
               </a:rPr>
-              <a:t>환경 반응 → 체크리스트 → ghost trace</a:t>
-            </a:r>
-            <a:endParaRPr lang="en-US" sz="1250" dirty="0"/>
-          </a:p>
-        </p:txBody>
-      </p:sp>
-      <p:sp>
-        <p:nvSpPr>
-          <p:cNvPr id="22" name="Shape 20"/>
-          <p:cNvSpPr/>
-          <p:nvPr/>
-        </p:nvSpPr>
-        <p:spPr>
-          <a:xfrm>
-            <a:off x="457200" y="3822192"/>
-            <a:ext cx="1417320" cy="566928"/>
+              <a:t>외워서 통과하는 시험이 아니라, 실험해서 통과하는 시험을 원한다</a:t>
+            </a:r>
+            <a:endParaRPr lang="en-US" sz="1150" dirty="0"/>
+          </a:p>
+        </p:txBody>
+      </p:sp>
+      <p:sp>
+        <p:nvSpPr>
+          <p:cNvPr id="11" name="Shape 9"/>
+          <p:cNvSpPr/>
+          <p:nvPr/>
+        </p:nvSpPr>
+        <p:spPr>
+          <a:xfrm>
+            <a:off x="457200" y="3840480"/>
+            <a:ext cx="8357616" cy="868680"/>
           </a:xfrm>
           <a:prstGeom prst="rect">
             <a:avLst/>
@@ -3507,7 +3356,7 @@
           <a:solidFill>
             <a:srgbClr val="221C3A"/>
           </a:solidFill>
-          <a:ln w="15240">
+          <a:ln w="12700">
             <a:solidFill>
               <a:srgbClr val="37305A"/>
             </a:solidFill>
@@ -3517,450 +3366,52 @@
       </p:sp>
       <p:sp>
         <p:nvSpPr>
-          <p:cNvPr id="23" name="Text 21"/>
-          <p:cNvSpPr/>
-          <p:nvPr/>
-        </p:nvSpPr>
-        <p:spPr>
-          <a:xfrm>
-            <a:off x="457200" y="3822192"/>
-            <a:ext cx="1417320" cy="566928"/>
-          </a:xfrm>
-          <a:prstGeom prst="rect">
-            <a:avLst/>
-          </a:prstGeom>
-          <a:noFill/>
-          <a:ln/>
-        </p:spPr>
-        <p:txBody>
-          <a:bodyPr wrap="square" rtlCol="0" anchor="ctr"/>
-          <a:lstStyle/>
-          <a:p>
-            <a:pPr algn="ctr" indent="0" marL="0">
+          <p:cNvPr id="12" name="Text 10"/>
+          <p:cNvSpPr/>
+          <p:nvPr/>
+        </p:nvSpPr>
+        <p:spPr>
+          <a:xfrm>
+            <a:off x="685800" y="3840480"/>
+            <a:ext cx="7955280" cy="868680"/>
+          </a:xfrm>
+          <a:prstGeom prst="rect">
+            <a:avLst/>
+          </a:prstGeom>
+          <a:noFill/>
+          <a:ln/>
+        </p:spPr>
+        <p:txBody>
+          <a:bodyPr wrap="square" lIns="0" tIns="0" rIns="0" bIns="0" rtlCol="0" anchor="ctr"/>
+          <a:lstStyle/>
+          <a:p>
+            <a:pPr indent="0" marL="0">
               <a:buNone/>
             </a:pPr>
             <a:r>
               <a:rPr lang="en-US" sz="1300" b="1" dirty="0">
                 <a:solidFill>
+                  <a:srgbClr val="F0B450"/>
+                </a:solidFill>
+                <a:latin typeface="Malgun Gothic" pitchFamily="34" charset="0"/>
+                <a:ea typeface="Malgun Gothic" pitchFamily="34" charset="-122"/>
+                <a:cs typeface="Malgun Gothic" pitchFamily="34" charset="-120"/>
+              </a:rPr>
+              <a:t>연구 질문  </a:t>
+            </a:r>
+            <a:pPr indent="0" marL="0">
+              <a:buNone/>
+            </a:pPr>
+            <a:r>
+              <a:rPr lang="en-US" sz="1350" dirty="0">
+                <a:solidFill>
                   <a:srgbClr val="F2EEFA"/>
                 </a:solidFill>
                 <a:latin typeface="Malgun Gothic" pitchFamily="34" charset="0"/>
                 <a:ea typeface="Malgun Gothic" pitchFamily="34" charset="-122"/>
                 <a:cs typeface="Malgun Gothic" pitchFamily="34" charset="-120"/>
               </a:rPr>
-              <a:t>관찰</a:t>
-            </a:r>
-            <a:endParaRPr lang="en-US" sz="1300" dirty="0"/>
-          </a:p>
-        </p:txBody>
-      </p:sp>
-      <p:sp>
-        <p:nvSpPr>
-          <p:cNvPr id="24" name="Text 22"/>
-          <p:cNvSpPr/>
-          <p:nvPr/>
-        </p:nvSpPr>
-        <p:spPr>
-          <a:xfrm>
-            <a:off x="1856232" y="3822192"/>
-            <a:ext cx="347472" cy="566928"/>
-          </a:xfrm>
-          <a:prstGeom prst="rect">
-            <a:avLst/>
-          </a:prstGeom>
-          <a:noFill/>
-          <a:ln/>
-        </p:spPr>
-        <p:txBody>
-          <a:bodyPr wrap="square" rtlCol="0" anchor="ctr"/>
-          <a:lstStyle/>
-          <a:p>
-            <a:pPr algn="ctr" indent="0" marL="0">
-              <a:buNone/>
-            </a:pPr>
-            <a:r>
-              <a:rPr lang="en-US" sz="1500" dirty="0">
-                <a:solidFill>
-                  <a:srgbClr val="F0B450"/>
-                </a:solidFill>
-                <a:latin typeface="Malgun Gothic" pitchFamily="34" charset="0"/>
-                <a:ea typeface="Malgun Gothic" pitchFamily="34" charset="-122"/>
-                <a:cs typeface="Malgun Gothic" pitchFamily="34" charset="-120"/>
-              </a:rPr>
-              <a:t>→</a:t>
-            </a:r>
-            <a:endParaRPr lang="en-US" sz="1500" dirty="0"/>
-          </a:p>
-        </p:txBody>
-      </p:sp>
-      <p:sp>
-        <p:nvSpPr>
-          <p:cNvPr id="25" name="Shape 23"/>
-          <p:cNvSpPr/>
-          <p:nvPr/>
-        </p:nvSpPr>
-        <p:spPr>
-          <a:xfrm>
-            <a:off x="2167128" y="3822192"/>
-            <a:ext cx="1417320" cy="566928"/>
-          </a:xfrm>
-          <a:prstGeom prst="rect">
-            <a:avLst/>
-          </a:prstGeom>
-          <a:solidFill>
-            <a:srgbClr val="221C3A"/>
-          </a:solidFill>
-          <a:ln w="15240">
-            <a:solidFill>
-              <a:srgbClr val="37305A"/>
-            </a:solidFill>
-            <a:prstDash val="solid"/>
-          </a:ln>
-        </p:spPr>
-      </p:sp>
-      <p:sp>
-        <p:nvSpPr>
-          <p:cNvPr id="26" name="Text 24"/>
-          <p:cNvSpPr/>
-          <p:nvPr/>
-        </p:nvSpPr>
-        <p:spPr>
-          <a:xfrm>
-            <a:off x="2167128" y="3822192"/>
-            <a:ext cx="1417320" cy="566928"/>
-          </a:xfrm>
-          <a:prstGeom prst="rect">
-            <a:avLst/>
-          </a:prstGeom>
-          <a:noFill/>
-          <a:ln/>
-        </p:spPr>
-        <p:txBody>
-          <a:bodyPr wrap="square" rtlCol="0" anchor="ctr"/>
-          <a:lstStyle/>
-          <a:p>
-            <a:pPr algn="ctr" indent="0" marL="0">
-              <a:buNone/>
-            </a:pPr>
-            <a:r>
-              <a:rPr lang="en-US" sz="1300" b="1" dirty="0">
-                <a:solidFill>
-                  <a:srgbClr val="F2EEFA"/>
-                </a:solidFill>
-                <a:latin typeface="Malgun Gothic" pitchFamily="34" charset="0"/>
-                <a:ea typeface="Malgun Gothic" pitchFamily="34" charset="-122"/>
-                <a:cs typeface="Malgun Gothic" pitchFamily="34" charset="-120"/>
-              </a:rPr>
-              <a:t>드로잉</a:t>
-            </a:r>
-            <a:endParaRPr lang="en-US" sz="1300" dirty="0"/>
-          </a:p>
-        </p:txBody>
-      </p:sp>
-      <p:sp>
-        <p:nvSpPr>
-          <p:cNvPr id="27" name="Text 25"/>
-          <p:cNvSpPr/>
-          <p:nvPr/>
-        </p:nvSpPr>
-        <p:spPr>
-          <a:xfrm>
-            <a:off x="3566160" y="3822192"/>
-            <a:ext cx="347472" cy="566928"/>
-          </a:xfrm>
-          <a:prstGeom prst="rect">
-            <a:avLst/>
-          </a:prstGeom>
-          <a:noFill/>
-          <a:ln/>
-        </p:spPr>
-        <p:txBody>
-          <a:bodyPr wrap="square" rtlCol="0" anchor="ctr"/>
-          <a:lstStyle/>
-          <a:p>
-            <a:pPr algn="ctr" indent="0" marL="0">
-              <a:buNone/>
-            </a:pPr>
-            <a:r>
-              <a:rPr lang="en-US" sz="1500" dirty="0">
-                <a:solidFill>
-                  <a:srgbClr val="F0B450"/>
-                </a:solidFill>
-                <a:latin typeface="Malgun Gothic" pitchFamily="34" charset="0"/>
-                <a:ea typeface="Malgun Gothic" pitchFamily="34" charset="-122"/>
-                <a:cs typeface="Malgun Gothic" pitchFamily="34" charset="-120"/>
-              </a:rPr>
-              <a:t>→</a:t>
-            </a:r>
-            <a:endParaRPr lang="en-US" sz="1500" dirty="0"/>
-          </a:p>
-        </p:txBody>
-      </p:sp>
-      <p:sp>
-        <p:nvSpPr>
-          <p:cNvPr id="28" name="Shape 26"/>
-          <p:cNvSpPr/>
-          <p:nvPr/>
-        </p:nvSpPr>
-        <p:spPr>
-          <a:xfrm>
-            <a:off x="3877056" y="3822192"/>
-            <a:ext cx="1417320" cy="566928"/>
-          </a:xfrm>
-          <a:prstGeom prst="rect">
-            <a:avLst/>
-          </a:prstGeom>
-          <a:solidFill>
-            <a:srgbClr val="221C3A"/>
-          </a:solidFill>
-          <a:ln w="15240">
-            <a:solidFill>
-              <a:srgbClr val="37305A"/>
-            </a:solidFill>
-            <a:prstDash val="solid"/>
-          </a:ln>
-        </p:spPr>
-      </p:sp>
-      <p:sp>
-        <p:nvSpPr>
-          <p:cNvPr id="29" name="Text 27"/>
-          <p:cNvSpPr/>
-          <p:nvPr/>
-        </p:nvSpPr>
-        <p:spPr>
-          <a:xfrm>
-            <a:off x="3877056" y="3822192"/>
-            <a:ext cx="1417320" cy="566928"/>
-          </a:xfrm>
-          <a:prstGeom prst="rect">
-            <a:avLst/>
-          </a:prstGeom>
-          <a:noFill/>
-          <a:ln/>
-        </p:spPr>
-        <p:txBody>
-          <a:bodyPr wrap="square" rtlCol="0" anchor="ctr"/>
-          <a:lstStyle/>
-          <a:p>
-            <a:pPr algn="ctr" indent="0" marL="0">
-              <a:buNone/>
-            </a:pPr>
-            <a:r>
-              <a:rPr lang="en-US" sz="1300" b="1" dirty="0">
-                <a:solidFill>
-                  <a:srgbClr val="F2EEFA"/>
-                </a:solidFill>
-                <a:latin typeface="Malgun Gothic" pitchFamily="34" charset="0"/>
-                <a:ea typeface="Malgun Gothic" pitchFamily="34" charset="-122"/>
-                <a:cs typeface="Malgun Gothic" pitchFamily="34" charset="-120"/>
-              </a:rPr>
-              <a:t>인식 · 품질</a:t>
-            </a:r>
-            <a:endParaRPr lang="en-US" sz="1300" dirty="0"/>
-          </a:p>
-        </p:txBody>
-      </p:sp>
-      <p:sp>
-        <p:nvSpPr>
-          <p:cNvPr id="30" name="Text 28"/>
-          <p:cNvSpPr/>
-          <p:nvPr/>
-        </p:nvSpPr>
-        <p:spPr>
-          <a:xfrm>
-            <a:off x="5276088" y="3822192"/>
-            <a:ext cx="347472" cy="566928"/>
-          </a:xfrm>
-          <a:prstGeom prst="rect">
-            <a:avLst/>
-          </a:prstGeom>
-          <a:noFill/>
-          <a:ln/>
-        </p:spPr>
-        <p:txBody>
-          <a:bodyPr wrap="square" rtlCol="0" anchor="ctr"/>
-          <a:lstStyle/>
-          <a:p>
-            <a:pPr algn="ctr" indent="0" marL="0">
-              <a:buNone/>
-            </a:pPr>
-            <a:r>
-              <a:rPr lang="en-US" sz="1500" dirty="0">
-                <a:solidFill>
-                  <a:srgbClr val="F0B450"/>
-                </a:solidFill>
-                <a:latin typeface="Malgun Gothic" pitchFamily="34" charset="0"/>
-                <a:ea typeface="Malgun Gothic" pitchFamily="34" charset="-122"/>
-                <a:cs typeface="Malgun Gothic" pitchFamily="34" charset="-120"/>
-              </a:rPr>
-              <a:t>→</a:t>
-            </a:r>
-            <a:endParaRPr lang="en-US" sz="1500" dirty="0"/>
-          </a:p>
-        </p:txBody>
-      </p:sp>
-      <p:sp>
-        <p:nvSpPr>
-          <p:cNvPr id="31" name="Shape 29"/>
-          <p:cNvSpPr/>
-          <p:nvPr/>
-        </p:nvSpPr>
-        <p:spPr>
-          <a:xfrm>
-            <a:off x="5586984" y="3822192"/>
-            <a:ext cx="1417320" cy="566928"/>
-          </a:xfrm>
-          <a:prstGeom prst="rect">
-            <a:avLst/>
-          </a:prstGeom>
-          <a:solidFill>
-            <a:srgbClr val="221C3A"/>
-          </a:solidFill>
-          <a:ln w="15240">
-            <a:solidFill>
-              <a:srgbClr val="37305A"/>
-            </a:solidFill>
-            <a:prstDash val="solid"/>
-          </a:ln>
-        </p:spPr>
-      </p:sp>
-      <p:sp>
-        <p:nvSpPr>
-          <p:cNvPr id="32" name="Text 30"/>
-          <p:cNvSpPr/>
-          <p:nvPr/>
-        </p:nvSpPr>
-        <p:spPr>
-          <a:xfrm>
-            <a:off x="5586984" y="3822192"/>
-            <a:ext cx="1417320" cy="566928"/>
-          </a:xfrm>
-          <a:prstGeom prst="rect">
-            <a:avLst/>
-          </a:prstGeom>
-          <a:noFill/>
-          <a:ln/>
-        </p:spPr>
-        <p:txBody>
-          <a:bodyPr wrap="square" rtlCol="0" anchor="ctr"/>
-          <a:lstStyle/>
-          <a:p>
-            <a:pPr algn="ctr" indent="0" marL="0">
-              <a:buNone/>
-            </a:pPr>
-            <a:r>
-              <a:rPr lang="en-US" sz="1300" b="1" dirty="0">
-                <a:solidFill>
-                  <a:srgbClr val="F2EEFA"/>
-                </a:solidFill>
-                <a:latin typeface="Malgun Gothic" pitchFamily="34" charset="0"/>
-                <a:ea typeface="Malgun Gothic" pitchFamily="34" charset="-122"/>
-                <a:cs typeface="Malgun Gothic" pitchFamily="34" charset="-120"/>
-              </a:rPr>
-              <a:t>세계 반응</a:t>
-            </a:r>
-            <a:endParaRPr lang="en-US" sz="1300" dirty="0"/>
-          </a:p>
-        </p:txBody>
-      </p:sp>
-      <p:sp>
-        <p:nvSpPr>
-          <p:cNvPr id="33" name="Text 31"/>
-          <p:cNvSpPr/>
-          <p:nvPr/>
-        </p:nvSpPr>
-        <p:spPr>
-          <a:xfrm>
-            <a:off x="6986016" y="3822192"/>
-            <a:ext cx="347472" cy="566928"/>
-          </a:xfrm>
-          <a:prstGeom prst="rect">
-            <a:avLst/>
-          </a:prstGeom>
-          <a:noFill/>
-          <a:ln/>
-        </p:spPr>
-        <p:txBody>
-          <a:bodyPr wrap="square" rtlCol="0" anchor="ctr"/>
-          <a:lstStyle/>
-          <a:p>
-            <a:pPr algn="ctr" indent="0" marL="0">
-              <a:buNone/>
-            </a:pPr>
-            <a:r>
-              <a:rPr lang="en-US" sz="1500" dirty="0">
-                <a:solidFill>
-                  <a:srgbClr val="F0B450"/>
-                </a:solidFill>
-                <a:latin typeface="Malgun Gothic" pitchFamily="34" charset="0"/>
-                <a:ea typeface="Malgun Gothic" pitchFamily="34" charset="-122"/>
-                <a:cs typeface="Malgun Gothic" pitchFamily="34" charset="-120"/>
-              </a:rPr>
-              <a:t>→</a:t>
-            </a:r>
-            <a:endParaRPr lang="en-US" sz="1500" dirty="0"/>
-          </a:p>
-        </p:txBody>
-      </p:sp>
-      <p:sp>
-        <p:nvSpPr>
-          <p:cNvPr id="34" name="Shape 32"/>
-          <p:cNvSpPr/>
-          <p:nvPr/>
-        </p:nvSpPr>
-        <p:spPr>
-          <a:xfrm>
-            <a:off x="7296912" y="3822192"/>
-            <a:ext cx="1417320" cy="566928"/>
-          </a:xfrm>
-          <a:prstGeom prst="rect">
-            <a:avLst/>
-          </a:prstGeom>
-          <a:solidFill>
-            <a:srgbClr val="2E2452"/>
-          </a:solidFill>
-          <a:ln w="15240">
-            <a:solidFill>
-              <a:srgbClr val="9D7BE8"/>
-            </a:solidFill>
-            <a:prstDash val="solid"/>
-          </a:ln>
-        </p:spPr>
-      </p:sp>
-      <p:sp>
-        <p:nvSpPr>
-          <p:cNvPr id="35" name="Text 33"/>
-          <p:cNvSpPr/>
-          <p:nvPr/>
-        </p:nvSpPr>
-        <p:spPr>
-          <a:xfrm>
-            <a:off x="7296912" y="3822192"/>
-            <a:ext cx="1417320" cy="566928"/>
-          </a:xfrm>
-          <a:prstGeom prst="rect">
-            <a:avLst/>
-          </a:prstGeom>
-          <a:noFill/>
-          <a:ln/>
-        </p:spPr>
-        <p:txBody>
-          <a:bodyPr wrap="square" rtlCol="0" anchor="ctr"/>
-          <a:lstStyle/>
-          <a:p>
-            <a:pPr algn="ctr" indent="0" marL="0">
-              <a:buNone/>
-            </a:pPr>
-            <a:r>
-              <a:rPr lang="en-US" sz="1300" b="1" dirty="0">
-                <a:solidFill>
-                  <a:srgbClr val="9D7BE8"/>
-                </a:solidFill>
-                <a:latin typeface="Malgun Gothic" pitchFamily="34" charset="0"/>
-                <a:ea typeface="Malgun Gothic" pitchFamily="34" charset="-122"/>
-                <a:cs typeface="Malgun Gothic" pitchFamily="34" charset="-120"/>
-              </a:rPr>
-              <a:t>조합 실험</a:t>
+              <a:t>기호 기반 입력이 재미와 몰입을 만들면서도, 실패 이유를 납득 가능하게 설명할 수 있는가? (GAME_DESIGN §1)</a:t>
             </a:r>
             <a:endParaRPr lang="en-US" sz="1300" dirty="0"/>
           </a:p>
@@ -4031,7 +3482,7 @@
                 <a:ea typeface="Malgun Gothic" pitchFamily="34" charset="-122"/>
                 <a:cs typeface="Malgun Gothic" pitchFamily="34" charset="-120"/>
               </a:rPr>
-              <a:t>구현</a:t>
+              <a:t>설계</a:t>
             </a:r>
             <a:endParaRPr lang="en-US" sz="1200" dirty="0"/>
           </a:p>
@@ -4070,7 +3521,7 @@
                 <a:ea typeface="Malgun Gothic" pitchFamily="34" charset="-122"/>
                 <a:cs typeface="Malgun Gothic" pitchFamily="34" charset="-120"/>
               </a:rPr>
-              <a:t>웹에서 검증하고, Unity로 이식</a:t>
+              <a:t>마법 문법 — 동사와 장식</a:t>
             </a:r>
             <a:endParaRPr lang="en-US" sz="3000" dirty="0"/>
           </a:p>
@@ -4126,7 +3577,7 @@
         <p:spPr>
           <a:xfrm>
             <a:off x="457200" y="1371600"/>
-            <a:ext cx="4023360" cy="1417320"/>
+            <a:ext cx="4023360" cy="2103120"/>
           </a:xfrm>
           <a:prstGeom prst="rect">
             <a:avLst/>
@@ -4150,7 +3601,7 @@
         </p:nvSpPr>
         <p:spPr>
           <a:xfrm>
-            <a:off x="658368" y="1499616"/>
+            <a:off x="658368" y="1517904"/>
             <a:ext cx="3657600" cy="274320"/>
           </a:xfrm>
           <a:prstGeom prst="rect">
@@ -4167,7 +3618,68 @@
               <a:buNone/>
             </a:pPr>
             <a:r>
-              <a:rPr lang="en-US" sz="1350" b="1" dirty="0">
+              <a:rPr lang="en-US" sz="1300" b="1" dirty="0">
+                <a:solidFill>
+                  <a:srgbClr val="F2EEFA"/>
+                </a:solidFill>
+                <a:latin typeface="Malgun Gothic" pitchFamily="34" charset="0"/>
+                <a:ea typeface="Malgun Gothic" pitchFamily="34" charset="-122"/>
+                <a:cs typeface="Malgun Gothic" pitchFamily="34" charset="-120"/>
+              </a:rPr>
+              <a:t>base 5종 — 세계를 바꾸는 동사</a:t>
+            </a:r>
+            <a:endParaRPr lang="en-US" sz="1300" dirty="0"/>
+          </a:p>
+        </p:txBody>
+      </p:sp>
+      <p:sp>
+        <p:nvSpPr>
+          <p:cNvPr id="7" name="Shape 5"/>
+          <p:cNvSpPr/>
+          <p:nvPr/>
+        </p:nvSpPr>
+        <p:spPr>
+          <a:xfrm>
+            <a:off x="658368" y="1828800"/>
+            <a:ext cx="566928" cy="566928"/>
+          </a:xfrm>
+          <a:prstGeom prst="ellipse">
+            <a:avLst/>
+          </a:prstGeom>
+          <a:ln w="19050">
+            <a:solidFill>
+              <a:srgbClr val="F0B450"/>
+            </a:solidFill>
+            <a:prstDash val="solid"/>
+          </a:ln>
+        </p:spPr>
+      </p:sp>
+      <p:sp>
+        <p:nvSpPr>
+          <p:cNvPr id="8" name="Text 6"/>
+          <p:cNvSpPr/>
+          <p:nvPr/>
+        </p:nvSpPr>
+        <p:spPr>
+          <a:xfrm>
+            <a:off x="658368" y="1828800"/>
+            <a:ext cx="566928" cy="566928"/>
+          </a:xfrm>
+          <a:prstGeom prst="rect">
+            <a:avLst/>
+          </a:prstGeom>
+          <a:noFill/>
+          <a:ln/>
+        </p:spPr>
+        <p:txBody>
+          <a:bodyPr wrap="square" rtlCol="0" anchor="ctr"/>
+          <a:lstStyle/>
+          <a:p>
+            <a:pPr algn="ctr" indent="0" marL="0">
+              <a:buNone/>
+            </a:pPr>
+            <a:r>
+              <a:rPr lang="en-US" sz="1100" dirty="0">
                 <a:solidFill>
                   <a:srgbClr val="F0B450"/>
                 </a:solidFill>
@@ -4175,22 +3687,266 @@
                 <a:ea typeface="Malgun Gothic" pitchFamily="34" charset="-122"/>
                 <a:cs typeface="Malgun Gothic" pitchFamily="34" charset="-120"/>
               </a:rPr>
-              <a:t>Track 1 — Web Recognizer Lab</a:t>
-            </a:r>
-            <a:endParaRPr lang="en-US" sz="1350" dirty="0"/>
-          </a:p>
-        </p:txBody>
-      </p:sp>
-      <p:sp>
-        <p:nvSpPr>
-          <p:cNvPr id="7" name="Text 5"/>
-          <p:cNvSpPr/>
-          <p:nvPr/>
-        </p:nvSpPr>
-        <p:spPr>
-          <a:xfrm>
-            <a:off x="658368" y="1810512"/>
-            <a:ext cx="3657600" cy="868680"/>
+              <a:t>불</a:t>
+            </a:r>
+            <a:endParaRPr lang="en-US" sz="1100" dirty="0"/>
+          </a:p>
+        </p:txBody>
+      </p:sp>
+      <p:sp>
+        <p:nvSpPr>
+          <p:cNvPr id="9" name="Shape 7"/>
+          <p:cNvSpPr/>
+          <p:nvPr/>
+        </p:nvSpPr>
+        <p:spPr>
+          <a:xfrm>
+            <a:off x="1371600" y="1828800"/>
+            <a:ext cx="566928" cy="566928"/>
+          </a:xfrm>
+          <a:prstGeom prst="ellipse">
+            <a:avLst/>
+          </a:prstGeom>
+          <a:ln w="19050">
+            <a:solidFill>
+              <a:srgbClr val="F0B450"/>
+            </a:solidFill>
+            <a:prstDash val="solid"/>
+          </a:ln>
+        </p:spPr>
+      </p:sp>
+      <p:sp>
+        <p:nvSpPr>
+          <p:cNvPr id="10" name="Text 8"/>
+          <p:cNvSpPr/>
+          <p:nvPr/>
+        </p:nvSpPr>
+        <p:spPr>
+          <a:xfrm>
+            <a:off x="1371600" y="1828800"/>
+            <a:ext cx="566928" cy="566928"/>
+          </a:xfrm>
+          <a:prstGeom prst="rect">
+            <a:avLst/>
+          </a:prstGeom>
+          <a:noFill/>
+          <a:ln/>
+        </p:spPr>
+        <p:txBody>
+          <a:bodyPr wrap="square" rtlCol="0" anchor="ctr"/>
+          <a:lstStyle/>
+          <a:p>
+            <a:pPr algn="ctr" indent="0" marL="0">
+              <a:buNone/>
+            </a:pPr>
+            <a:r>
+              <a:rPr lang="en-US" sz="1100" dirty="0">
+                <a:solidFill>
+                  <a:srgbClr val="F0B450"/>
+                </a:solidFill>
+                <a:latin typeface="Malgun Gothic" pitchFamily="34" charset="0"/>
+                <a:ea typeface="Malgun Gothic" pitchFamily="34" charset="-122"/>
+                <a:cs typeface="Malgun Gothic" pitchFamily="34" charset="-120"/>
+              </a:rPr>
+              <a:t>물</a:t>
+            </a:r>
+            <a:endParaRPr lang="en-US" sz="1100" dirty="0"/>
+          </a:p>
+        </p:txBody>
+      </p:sp>
+      <p:sp>
+        <p:nvSpPr>
+          <p:cNvPr id="11" name="Shape 9"/>
+          <p:cNvSpPr/>
+          <p:nvPr/>
+        </p:nvSpPr>
+        <p:spPr>
+          <a:xfrm>
+            <a:off x="2084832" y="1828800"/>
+            <a:ext cx="566928" cy="566928"/>
+          </a:xfrm>
+          <a:prstGeom prst="ellipse">
+            <a:avLst/>
+          </a:prstGeom>
+          <a:ln w="19050">
+            <a:solidFill>
+              <a:srgbClr val="F0B450"/>
+            </a:solidFill>
+            <a:prstDash val="solid"/>
+          </a:ln>
+        </p:spPr>
+      </p:sp>
+      <p:sp>
+        <p:nvSpPr>
+          <p:cNvPr id="12" name="Text 10"/>
+          <p:cNvSpPr/>
+          <p:nvPr/>
+        </p:nvSpPr>
+        <p:spPr>
+          <a:xfrm>
+            <a:off x="2084832" y="1828800"/>
+            <a:ext cx="566928" cy="566928"/>
+          </a:xfrm>
+          <a:prstGeom prst="rect">
+            <a:avLst/>
+          </a:prstGeom>
+          <a:noFill/>
+          <a:ln/>
+        </p:spPr>
+        <p:txBody>
+          <a:bodyPr wrap="square" rtlCol="0" anchor="ctr"/>
+          <a:lstStyle/>
+          <a:p>
+            <a:pPr algn="ctr" indent="0" marL="0">
+              <a:buNone/>
+            </a:pPr>
+            <a:r>
+              <a:rPr lang="en-US" sz="1100" dirty="0">
+                <a:solidFill>
+                  <a:srgbClr val="F0B450"/>
+                </a:solidFill>
+                <a:latin typeface="Malgun Gothic" pitchFamily="34" charset="0"/>
+                <a:ea typeface="Malgun Gothic" pitchFamily="34" charset="-122"/>
+                <a:cs typeface="Malgun Gothic" pitchFamily="34" charset="-120"/>
+              </a:rPr>
+              <a:t>바람</a:t>
+            </a:r>
+            <a:endParaRPr lang="en-US" sz="1100" dirty="0"/>
+          </a:p>
+        </p:txBody>
+      </p:sp>
+      <p:sp>
+        <p:nvSpPr>
+          <p:cNvPr id="13" name="Shape 11"/>
+          <p:cNvSpPr/>
+          <p:nvPr/>
+        </p:nvSpPr>
+        <p:spPr>
+          <a:xfrm>
+            <a:off x="2798064" y="1828800"/>
+            <a:ext cx="566928" cy="566928"/>
+          </a:xfrm>
+          <a:prstGeom prst="ellipse">
+            <a:avLst/>
+          </a:prstGeom>
+          <a:ln w="19050">
+            <a:solidFill>
+              <a:srgbClr val="F0B450"/>
+            </a:solidFill>
+            <a:prstDash val="solid"/>
+          </a:ln>
+        </p:spPr>
+      </p:sp>
+      <p:sp>
+        <p:nvSpPr>
+          <p:cNvPr id="14" name="Text 12"/>
+          <p:cNvSpPr/>
+          <p:nvPr/>
+        </p:nvSpPr>
+        <p:spPr>
+          <a:xfrm>
+            <a:off x="2798064" y="1828800"/>
+            <a:ext cx="566928" cy="566928"/>
+          </a:xfrm>
+          <a:prstGeom prst="rect">
+            <a:avLst/>
+          </a:prstGeom>
+          <a:noFill/>
+          <a:ln/>
+        </p:spPr>
+        <p:txBody>
+          <a:bodyPr wrap="square" rtlCol="0" anchor="ctr"/>
+          <a:lstStyle/>
+          <a:p>
+            <a:pPr algn="ctr" indent="0" marL="0">
+              <a:buNone/>
+            </a:pPr>
+            <a:r>
+              <a:rPr lang="en-US" sz="1100" dirty="0">
+                <a:solidFill>
+                  <a:srgbClr val="F0B450"/>
+                </a:solidFill>
+                <a:latin typeface="Malgun Gothic" pitchFamily="34" charset="0"/>
+                <a:ea typeface="Malgun Gothic" pitchFamily="34" charset="-122"/>
+                <a:cs typeface="Malgun Gothic" pitchFamily="34" charset="-120"/>
+              </a:rPr>
+              <a:t>땅</a:t>
+            </a:r>
+            <a:endParaRPr lang="en-US" sz="1100" dirty="0"/>
+          </a:p>
+        </p:txBody>
+      </p:sp>
+      <p:sp>
+        <p:nvSpPr>
+          <p:cNvPr id="15" name="Shape 13"/>
+          <p:cNvSpPr/>
+          <p:nvPr/>
+        </p:nvSpPr>
+        <p:spPr>
+          <a:xfrm>
+            <a:off x="3511296" y="1828800"/>
+            <a:ext cx="566928" cy="566928"/>
+          </a:xfrm>
+          <a:prstGeom prst="ellipse">
+            <a:avLst/>
+          </a:prstGeom>
+          <a:ln w="19050">
+            <a:solidFill>
+              <a:srgbClr val="F0B450"/>
+            </a:solidFill>
+            <a:prstDash val="solid"/>
+          </a:ln>
+        </p:spPr>
+      </p:sp>
+      <p:sp>
+        <p:nvSpPr>
+          <p:cNvPr id="16" name="Text 14"/>
+          <p:cNvSpPr/>
+          <p:nvPr/>
+        </p:nvSpPr>
+        <p:spPr>
+          <a:xfrm>
+            <a:off x="3511296" y="1828800"/>
+            <a:ext cx="566928" cy="566928"/>
+          </a:xfrm>
+          <a:prstGeom prst="rect">
+            <a:avLst/>
+          </a:prstGeom>
+          <a:noFill/>
+          <a:ln/>
+        </p:spPr>
+        <p:txBody>
+          <a:bodyPr wrap="square" rtlCol="0" anchor="ctr"/>
+          <a:lstStyle/>
+          <a:p>
+            <a:pPr algn="ctr" indent="0" marL="0">
+              <a:buNone/>
+            </a:pPr>
+            <a:r>
+              <a:rPr lang="en-US" sz="1100" dirty="0">
+                <a:solidFill>
+                  <a:srgbClr val="F0B450"/>
+                </a:solidFill>
+                <a:latin typeface="Malgun Gothic" pitchFamily="34" charset="0"/>
+                <a:ea typeface="Malgun Gothic" pitchFamily="34" charset="-122"/>
+                <a:cs typeface="Malgun Gothic" pitchFamily="34" charset="-120"/>
+              </a:rPr>
+              <a:t>생명</a:t>
+            </a:r>
+            <a:endParaRPr lang="en-US" sz="1100" dirty="0"/>
+          </a:p>
+        </p:txBody>
+      </p:sp>
+      <p:sp>
+        <p:nvSpPr>
+          <p:cNvPr id="17" name="Text 15"/>
+          <p:cNvSpPr/>
+          <p:nvPr/>
+        </p:nvSpPr>
+        <p:spPr>
+          <a:xfrm>
+            <a:off x="658368" y="2542032"/>
+            <a:ext cx="3657600" cy="274320"/>
           </a:xfrm>
           <a:prstGeom prst="rect">
             <a:avLst/>
@@ -4206,7 +3962,7 @@
               <a:buNone/>
             </a:pPr>
             <a:r>
-              <a:rPr lang="en-US" sz="1200" dirty="0">
+              <a:rPr lang="en-US" sz="1300" b="1" dirty="0">
                 <a:solidFill>
                   <a:srgbClr val="F2EEFA"/>
                 </a:solidFill>
@@ -4214,78 +3970,61 @@
                 <a:ea typeface="Malgun Gothic" pitchFamily="34" charset="-122"/>
                 <a:cs typeface="Malgun Gothic" pitchFamily="34" charset="-120"/>
               </a:rPr>
-              <a:t>빠른 인식 실험 · 대시보드 · 설문 수집</a:t>
-            </a:r>
-            <a:endParaRPr lang="en-US" sz="1200" dirty="0"/>
-          </a:p>
-          <a:p>
-            <a:pPr indent="0" marL="0">
-              <a:buNone/>
-            </a:pPr>
-            <a:r>
-              <a:rPr lang="en-US" sz="1200" dirty="0">
-                <a:solidFill>
-                  <a:srgbClr val="F2EEFA"/>
-                </a:solidFill>
-                <a:latin typeface="Malgun Gothic" pitchFamily="34" charset="0"/>
-                <a:ea typeface="Malgun Gothic" pitchFamily="34" charset="-122"/>
-                <a:cs typeface="Malgun Gothic" pitchFamily="34" charset="-120"/>
-              </a:rPr>
-              <a:t>stroke session → 특징 추출 → family + quality vector</a:t>
-            </a:r>
-            <a:endParaRPr lang="en-US" sz="1200" dirty="0"/>
-          </a:p>
-        </p:txBody>
-      </p:sp>
-      <p:sp>
-        <p:nvSpPr>
-          <p:cNvPr id="8" name="Text 6"/>
-          <p:cNvSpPr/>
-          <p:nvPr/>
-        </p:nvSpPr>
-        <p:spPr>
-          <a:xfrm>
-            <a:off x="4480560" y="1371600"/>
-            <a:ext cx="228600" cy="1417320"/>
-          </a:xfrm>
-          <a:prstGeom prst="rect">
-            <a:avLst/>
-          </a:prstGeom>
-          <a:noFill/>
-          <a:ln/>
-        </p:spPr>
-        <p:txBody>
-          <a:bodyPr wrap="square" rtlCol="0" anchor="ctr"/>
-          <a:lstStyle/>
-          <a:p>
-            <a:pPr algn="ctr" indent="0" marL="0">
-              <a:buNone/>
-            </a:pPr>
-            <a:r>
-              <a:rPr lang="en-US" sz="1800" dirty="0">
-                <a:solidFill>
-                  <a:srgbClr val="F0B450"/>
-                </a:solidFill>
-                <a:latin typeface="Malgun Gothic" pitchFamily="34" charset="0"/>
-                <a:ea typeface="Malgun Gothic" pitchFamily="34" charset="-122"/>
-                <a:cs typeface="Malgun Gothic" pitchFamily="34" charset="-120"/>
-              </a:rPr>
-              <a:t>→</a:t>
-            </a:r>
-            <a:endParaRPr lang="en-US" sz="1800" dirty="0"/>
-          </a:p>
-        </p:txBody>
-      </p:sp>
-      <p:sp>
-        <p:nvSpPr>
-          <p:cNvPr id="9" name="Shape 7"/>
-          <p:cNvSpPr/>
-          <p:nvPr/>
-        </p:nvSpPr>
-        <p:spPr>
-          <a:xfrm>
-            <a:off x="4709160" y="1371600"/>
-            <a:ext cx="4105656" cy="1417320"/>
+              <a:t>overlay 6종 — 동사를 바꾸는 장식</a:t>
+            </a:r>
+            <a:endParaRPr lang="en-US" sz="1300" dirty="0"/>
+          </a:p>
+        </p:txBody>
+      </p:sp>
+      <p:sp>
+        <p:nvSpPr>
+          <p:cNvPr id="18" name="Text 16"/>
+          <p:cNvSpPr/>
+          <p:nvPr/>
+        </p:nvSpPr>
+        <p:spPr>
+          <a:xfrm>
+            <a:off x="658368" y="2816352"/>
+            <a:ext cx="3657600" cy="548640"/>
+          </a:xfrm>
+          <a:prstGeom prst="rect">
+            <a:avLst/>
+          </a:prstGeom>
+          <a:noFill/>
+          <a:ln/>
+        </p:spPr>
+        <p:txBody>
+          <a:bodyPr wrap="square" lIns="0" tIns="0" rIns="0" bIns="0" rtlCol="0" anchor="ctr"/>
+          <a:lstStyle/>
+          <a:p>
+            <a:pPr indent="0" marL="0">
+              <a:buNone/>
+            </a:pPr>
+            <a:r>
+              <a:rPr lang="en-US" sz="1150" dirty="0">
+                <a:solidFill>
+                  <a:srgbClr val="9D7BE8"/>
+                </a:solidFill>
+                <a:latin typeface="Malgun Gothic" pitchFamily="34" charset="0"/>
+                <a:ea typeface="Malgun Gothic" pitchFamily="34" charset="-122"/>
+                <a:cs typeface="Malgun Gothic" pitchFamily="34" charset="-120"/>
+              </a:rPr>
+              <a:t>ice_bar · steel_brace · soul_dot · electric_fork · void_cut → martial_axis (의존성: void_cut 이후에만)</a:t>
+            </a:r>
+            <a:endParaRPr lang="en-US" sz="1150" dirty="0"/>
+          </a:p>
+        </p:txBody>
+      </p:sp>
+      <p:sp>
+        <p:nvSpPr>
+          <p:cNvPr id="19" name="Shape 17"/>
+          <p:cNvSpPr/>
+          <p:nvPr/>
+        </p:nvSpPr>
+        <p:spPr>
+          <a:xfrm>
+            <a:off x="4663440" y="1371600"/>
+            <a:ext cx="4151376" cy="2103120"/>
           </a:xfrm>
           <a:prstGeom prst="rect">
             <a:avLst/>
@@ -4303,13 +4042,13 @@
       </p:sp>
       <p:sp>
         <p:nvSpPr>
-          <p:cNvPr id="10" name="Text 8"/>
-          <p:cNvSpPr/>
-          <p:nvPr/>
-        </p:nvSpPr>
-        <p:spPr>
-          <a:xfrm>
-            <a:off x="4910328" y="1499616"/>
+          <p:cNvPr id="20" name="Text 18"/>
+          <p:cNvSpPr/>
+          <p:nvPr/>
+        </p:nvSpPr>
+        <p:spPr>
+          <a:xfrm>
+            <a:off x="4864608" y="1517904"/>
             <a:ext cx="3749040" cy="274320"/>
           </a:xfrm>
           <a:prstGeom prst="rect">
@@ -4326,7 +4065,49 @@
               <a:buNone/>
             </a:pPr>
             <a:r>
-              <a:rPr lang="en-US" sz="1350" b="1" dirty="0">
+              <a:rPr lang="en-US" sz="1300" b="1" dirty="0">
+                <a:solidFill>
+                  <a:srgbClr val="F2EEFA"/>
+                </a:solidFill>
+                <a:latin typeface="Malgun Gothic" pitchFamily="34" charset="0"/>
+                <a:ea typeface="Malgun Gothic" pitchFamily="34" charset="-122"/>
+                <a:cs typeface="Malgun Gothic" pitchFamily="34" charset="-120"/>
+              </a:rPr>
+              <a:t>형태가 종류를, 품질이 세기를</a:t>
+            </a:r>
+            <a:endParaRPr lang="en-US" sz="1300" dirty="0"/>
+          </a:p>
+        </p:txBody>
+      </p:sp>
+      <p:sp>
+        <p:nvSpPr>
+          <p:cNvPr id="21" name="Text 19"/>
+          <p:cNvSpPr/>
+          <p:nvPr/>
+        </p:nvSpPr>
+        <p:spPr>
+          <a:xfrm>
+            <a:off x="4864608" y="1828800"/>
+            <a:ext cx="3749040" cy="1463040"/>
+          </a:xfrm>
+          <a:prstGeom prst="rect">
+            <a:avLst/>
+          </a:prstGeom>
+          <a:noFill/>
+          <a:ln/>
+        </p:spPr>
+        <p:txBody>
+          <a:bodyPr wrap="square" lIns="0" tIns="0" rIns="0" bIns="0" rtlCol="0" anchor="ctr"/>
+          <a:lstStyle/>
+          <a:p>
+            <a:pPr indent="0" marL="0">
+              <a:spcAft>
+                <a:spcPts val="600"/>
+              </a:spcAft>
+              <a:buNone/>
+            </a:pPr>
+            <a:r>
+              <a:rPr lang="en-US" sz="1250" b="1" dirty="0">
                 <a:solidFill>
                   <a:srgbClr val="F0B450"/>
                 </a:solidFill>
@@ -4334,38 +4115,16 @@
                 <a:ea typeface="Malgun Gothic" pitchFamily="34" charset="-122"/>
                 <a:cs typeface="Malgun Gothic" pitchFamily="34" charset="-120"/>
               </a:rPr>
-              <a:t>Track 2 — Unity Playable (5층 시험장)</a:t>
-            </a:r>
-            <a:endParaRPr lang="en-US" sz="1350" dirty="0"/>
-          </a:p>
-        </p:txBody>
-      </p:sp>
-      <p:sp>
-        <p:nvSpPr>
-          <p:cNvPr id="11" name="Text 9"/>
-          <p:cNvSpPr/>
-          <p:nvPr/>
-        </p:nvSpPr>
-        <p:spPr>
-          <a:xfrm>
-            <a:off x="4910328" y="1810512"/>
-            <a:ext cx="3749040" cy="868680"/>
-          </a:xfrm>
-          <a:prstGeom prst="rect">
-            <a:avLst/>
-          </a:prstGeom>
-          <a:noFill/>
-          <a:ln/>
-        </p:spPr>
-        <p:txBody>
-          <a:bodyPr wrap="square" lIns="0" tIns="0" rIns="0" bIns="0" rtlCol="0" anchor="ctr"/>
-          <a:lstStyle/>
-          <a:p>
-            <a:pPr indent="0" marL="0">
-              <a:buNone/>
-            </a:pPr>
-            <a:r>
-              <a:rPr lang="en-US" sz="1200" dirty="0">
+              <a:t>family </a:t>
+            </a:r>
+            <a:pPr indent="0" marL="0">
+              <a:spcAft>
+                <a:spcPts val="600"/>
+              </a:spcAft>
+              <a:buNone/>
+            </a:pPr>
+            <a:r>
+              <a:rPr lang="en-US" sz="1250" dirty="0">
                 <a:solidFill>
                   <a:srgbClr val="F2EEFA"/>
                 </a:solidFill>
@@ -4373,16 +4132,33 @@
                 <a:ea typeface="Malgun Gothic" pitchFamily="34" charset="-122"/>
                 <a:cs typeface="Malgun Gothic" pitchFamily="34" charset="-120"/>
               </a:rPr>
-              <a:t>URP 2D 라이트 · 절차 SFX + 파일 우선 BGM 로더</a:t>
-            </a:r>
-            <a:endParaRPr lang="en-US" sz="1200" dirty="0"/>
-          </a:p>
-          <a:p>
-            <a:pPr indent="0" marL="0">
-              <a:buNone/>
-            </a:pPr>
-            <a:r>
-              <a:rPr lang="en-US" sz="1200" dirty="0">
+              <a:t>(무엇이 되는가)와 </a:t>
+            </a:r>
+            <a:pPr indent="0" marL="0">
+              <a:spcAft>
+                <a:spcPts val="600"/>
+              </a:spcAft>
+              <a:buNone/>
+            </a:pPr>
+            <a:r>
+              <a:rPr lang="en-US" sz="1250" b="1" dirty="0">
+                <a:solidFill>
+                  <a:srgbClr val="F0B450"/>
+                </a:solidFill>
+                <a:latin typeface="Malgun Gothic" pitchFamily="34" charset="0"/>
+                <a:ea typeface="Malgun Gothic" pitchFamily="34" charset="-122"/>
+                <a:cs typeface="Malgun Gothic" pitchFamily="34" charset="-120"/>
+              </a:rPr>
+              <a:t>quality</a:t>
+            </a:r>
+            <a:pPr indent="0" marL="0">
+              <a:spcAft>
+                <a:spcPts val="600"/>
+              </a:spcAft>
+              <a:buNone/>
+            </a:pPr>
+            <a:r>
+              <a:rPr lang="en-US" sz="1250" dirty="0">
                 <a:solidFill>
                   <a:srgbClr val="F2EEFA"/>
                 </a:solidFill>
@@ -4390,38 +4166,19 @@
                 <a:ea typeface="Malgun Gothic" pitchFamily="34" charset="-122"/>
                 <a:cs typeface="Malgun Gothic" pitchFamily="34" charset="-120"/>
               </a:rPr>
-              <a:t>멘토 NPC · codex · 엔딩 분기 (5/6 통과 · 6/6 진엔딩)</a:t>
-            </a:r>
-            <a:endParaRPr lang="en-US" sz="1200" dirty="0"/>
-          </a:p>
-        </p:txBody>
-      </p:sp>
-      <p:sp>
-        <p:nvSpPr>
-          <p:cNvPr id="12" name="Text 10"/>
-          <p:cNvSpPr/>
-          <p:nvPr/>
-        </p:nvSpPr>
-        <p:spPr>
-          <a:xfrm>
-            <a:off x="457200" y="3063240"/>
-            <a:ext cx="8229600" cy="292608"/>
-          </a:xfrm>
-          <a:prstGeom prst="rect">
-            <a:avLst/>
-          </a:prstGeom>
-          <a:noFill/>
-          <a:ln/>
-        </p:spPr>
-        <p:txBody>
-          <a:bodyPr wrap="square" lIns="0" tIns="0" rIns="0" bIns="0" rtlCol="0" anchor="ctr"/>
-          <a:lstStyle/>
-          <a:p>
-            <a:pPr indent="0" marL="0">
-              <a:buNone/>
-            </a:pPr>
-            <a:r>
-              <a:rPr lang="en-US" sz="1300" b="1" dirty="0">
+              <a:t> (얼마나 강한가)의 분리</a:t>
+            </a:r>
+            <a:endParaRPr lang="en-US" sz="1250" dirty="0"/>
+          </a:p>
+          <a:p>
+            <a:pPr indent="0" marL="0">
+              <a:spcAft>
+                <a:spcPts val="600"/>
+              </a:spcAft>
+              <a:buNone/>
+            </a:pPr>
+            <a:r>
+              <a:rPr lang="en-US" sz="1250" b="1" dirty="0">
                 <a:solidFill>
                   <a:srgbClr val="F2EEFA"/>
                 </a:solidFill>
@@ -4429,22 +4186,42 @@
                 <a:ea typeface="Malgun Gothic" pitchFamily="34" charset="-122"/>
                 <a:cs typeface="Malgun Gothic" pitchFamily="34" charset="-120"/>
               </a:rPr>
-              <a:t>검증 자동화 — 전부 자동으로 다시 돌릴 수 있다</a:t>
-            </a:r>
-            <a:endParaRPr lang="en-US" sz="1300" dirty="0"/>
-          </a:p>
-        </p:txBody>
-      </p:sp>
-      <p:sp>
-        <p:nvSpPr>
-          <p:cNvPr id="13" name="Shape 11"/>
-          <p:cNvSpPr/>
-          <p:nvPr/>
-        </p:nvSpPr>
-        <p:spPr>
-          <a:xfrm>
-            <a:off x="457200" y="3456432"/>
-            <a:ext cx="1956816" cy="1207008"/>
+              <a:t>실패 처리: 단계적 힌트 escalator</a:t>
+            </a:r>
+            <a:endParaRPr lang="en-US" sz="1250" dirty="0"/>
+          </a:p>
+          <a:p>
+            <a:pPr indent="0" marL="0">
+              <a:spcAft>
+                <a:spcPts val="600"/>
+              </a:spcAft>
+              <a:buNone/>
+            </a:pPr>
+            <a:r>
+              <a:rPr lang="en-US" sz="1250" dirty="0">
+                <a:solidFill>
+                  <a:srgbClr val="9A92B8"/>
+                </a:solidFill>
+                <a:latin typeface="Malgun Gothic" pitchFamily="34" charset="0"/>
+                <a:ea typeface="Malgun Gothic" pitchFamily="34" charset="-122"/>
+                <a:cs typeface="Malgun Gothic" pitchFamily="34" charset="-120"/>
+              </a:rPr>
+              <a:t>환경 반응 → 체크리스트 → ghost trace</a:t>
+            </a:r>
+            <a:endParaRPr lang="en-US" sz="1250" dirty="0"/>
+          </a:p>
+        </p:txBody>
+      </p:sp>
+      <p:sp>
+        <p:nvSpPr>
+          <p:cNvPr id="22" name="Shape 20"/>
+          <p:cNvSpPr/>
+          <p:nvPr/>
+        </p:nvSpPr>
+        <p:spPr>
+          <a:xfrm>
+            <a:off x="457200" y="3822192"/>
+            <a:ext cx="1417320" cy="566928"/>
           </a:xfrm>
           <a:prstGeom prst="rect">
             <a:avLst/>
@@ -4452,7 +4229,7 @@
           <a:solidFill>
             <a:srgbClr val="221C3A"/>
           </a:solidFill>
-          <a:ln w="12700">
+          <a:ln w="15240">
             <a:solidFill>
               <a:srgbClr val="37305A"/>
             </a:solidFill>
@@ -4462,14 +4239,14 @@
       </p:sp>
       <p:sp>
         <p:nvSpPr>
-          <p:cNvPr id="14" name="Text 12"/>
-          <p:cNvSpPr/>
-          <p:nvPr/>
-        </p:nvSpPr>
-        <p:spPr>
-          <a:xfrm>
-            <a:off x="457200" y="3566160"/>
-            <a:ext cx="1956816" cy="566928"/>
+          <p:cNvPr id="23" name="Text 21"/>
+          <p:cNvSpPr/>
+          <p:nvPr/>
+        </p:nvSpPr>
+        <p:spPr>
+          <a:xfrm>
+            <a:off x="457200" y="3822192"/>
+            <a:ext cx="1417320" cy="566928"/>
           </a:xfrm>
           <a:prstGeom prst="rect">
             <a:avLst/>
@@ -4485,30 +4262,30 @@
               <a:buNone/>
             </a:pPr>
             <a:r>
-              <a:rPr lang="en-US" sz="3000" b="1" dirty="0">
-                <a:solidFill>
-                  <a:srgbClr val="6FD98A"/>
-                </a:solidFill>
-                <a:latin typeface="Malgun Gothic" pitchFamily="34" charset="0"/>
-                <a:ea typeface="Malgun Gothic" pitchFamily="34" charset="-122"/>
-                <a:cs typeface="Malgun Gothic" pitchFamily="34" charset="-120"/>
-              </a:rPr>
-              <a:t>181</a:t>
-            </a:r>
-            <a:endParaRPr lang="en-US" sz="3000" dirty="0"/>
-          </a:p>
-        </p:txBody>
-      </p:sp>
-      <p:sp>
-        <p:nvSpPr>
-          <p:cNvPr id="15" name="Text 13"/>
-          <p:cNvSpPr/>
-          <p:nvPr/>
-        </p:nvSpPr>
-        <p:spPr>
-          <a:xfrm>
-            <a:off x="457200" y="4169664"/>
-            <a:ext cx="1956816" cy="365760"/>
+              <a:rPr lang="en-US" sz="1300" b="1" dirty="0">
+                <a:solidFill>
+                  <a:srgbClr val="F2EEFA"/>
+                </a:solidFill>
+                <a:latin typeface="Malgun Gothic" pitchFamily="34" charset="0"/>
+                <a:ea typeface="Malgun Gothic" pitchFamily="34" charset="-122"/>
+                <a:cs typeface="Malgun Gothic" pitchFamily="34" charset="-120"/>
+              </a:rPr>
+              <a:t>관찰</a:t>
+            </a:r>
+            <a:endParaRPr lang="en-US" sz="1300" dirty="0"/>
+          </a:p>
+        </p:txBody>
+      </p:sp>
+      <p:sp>
+        <p:nvSpPr>
+          <p:cNvPr id="24" name="Text 22"/>
+          <p:cNvSpPr/>
+          <p:nvPr/>
+        </p:nvSpPr>
+        <p:spPr>
+          <a:xfrm>
+            <a:off x="1856232" y="3822192"/>
+            <a:ext cx="347472" cy="566928"/>
           </a:xfrm>
           <a:prstGeom prst="rect">
             <a:avLst/>
@@ -4524,30 +4301,30 @@
               <a:buNone/>
             </a:pPr>
             <a:r>
-              <a:rPr lang="en-US" sz="1150" dirty="0">
-                <a:solidFill>
-                  <a:srgbClr val="9A92B8"/>
-                </a:solidFill>
-                <a:latin typeface="Malgun Gothic" pitchFamily="34" charset="0"/>
-                <a:ea typeface="Malgun Gothic" pitchFamily="34" charset="-122"/>
-                <a:cs typeface="Malgun Gothic" pitchFamily="34" charset="-120"/>
-              </a:rPr>
-              <a:t>Web 테스트 (Vitest)</a:t>
-            </a:r>
-            <a:endParaRPr lang="en-US" sz="1150" dirty="0"/>
-          </a:p>
-        </p:txBody>
-      </p:sp>
-      <p:sp>
-        <p:nvSpPr>
-          <p:cNvPr id="16" name="Shape 14"/>
-          <p:cNvSpPr/>
-          <p:nvPr/>
-        </p:nvSpPr>
-        <p:spPr>
-          <a:xfrm>
-            <a:off x="2615184" y="3456432"/>
-            <a:ext cx="1956816" cy="1207008"/>
+              <a:rPr lang="en-US" sz="1500" dirty="0">
+                <a:solidFill>
+                  <a:srgbClr val="F0B450"/>
+                </a:solidFill>
+                <a:latin typeface="Malgun Gothic" pitchFamily="34" charset="0"/>
+                <a:ea typeface="Malgun Gothic" pitchFamily="34" charset="-122"/>
+                <a:cs typeface="Malgun Gothic" pitchFamily="34" charset="-120"/>
+              </a:rPr>
+              <a:t>→</a:t>
+            </a:r>
+            <a:endParaRPr lang="en-US" sz="1500" dirty="0"/>
+          </a:p>
+        </p:txBody>
+      </p:sp>
+      <p:sp>
+        <p:nvSpPr>
+          <p:cNvPr id="25" name="Shape 23"/>
+          <p:cNvSpPr/>
+          <p:nvPr/>
+        </p:nvSpPr>
+        <p:spPr>
+          <a:xfrm>
+            <a:off x="2167128" y="3822192"/>
+            <a:ext cx="1417320" cy="566928"/>
           </a:xfrm>
           <a:prstGeom prst="rect">
             <a:avLst/>
@@ -4555,7 +4332,7 @@
           <a:solidFill>
             <a:srgbClr val="221C3A"/>
           </a:solidFill>
-          <a:ln w="12700">
+          <a:ln w="15240">
             <a:solidFill>
               <a:srgbClr val="37305A"/>
             </a:solidFill>
@@ -4565,14 +4342,14 @@
       </p:sp>
       <p:sp>
         <p:nvSpPr>
-          <p:cNvPr id="17" name="Text 15"/>
-          <p:cNvSpPr/>
-          <p:nvPr/>
-        </p:nvSpPr>
-        <p:spPr>
-          <a:xfrm>
-            <a:off x="2615184" y="3566160"/>
-            <a:ext cx="1956816" cy="566928"/>
+          <p:cNvPr id="26" name="Text 24"/>
+          <p:cNvSpPr/>
+          <p:nvPr/>
+        </p:nvSpPr>
+        <p:spPr>
+          <a:xfrm>
+            <a:off x="2167128" y="3822192"/>
+            <a:ext cx="1417320" cy="566928"/>
           </a:xfrm>
           <a:prstGeom prst="rect">
             <a:avLst/>
@@ -4588,30 +4365,30 @@
               <a:buNone/>
             </a:pPr>
             <a:r>
-              <a:rPr lang="en-US" sz="3000" b="1" dirty="0">
-                <a:solidFill>
-                  <a:srgbClr val="6FD98A"/>
-                </a:solidFill>
-                <a:latin typeface="Malgun Gothic" pitchFamily="34" charset="0"/>
-                <a:ea typeface="Malgun Gothic" pitchFamily="34" charset="-122"/>
-                <a:cs typeface="Malgun Gothic" pitchFamily="34" charset="-120"/>
-              </a:rPr>
-              <a:t>105</a:t>
-            </a:r>
-            <a:endParaRPr lang="en-US" sz="3000" dirty="0"/>
-          </a:p>
-        </p:txBody>
-      </p:sp>
-      <p:sp>
-        <p:nvSpPr>
-          <p:cNvPr id="18" name="Text 16"/>
-          <p:cNvSpPr/>
-          <p:nvPr/>
-        </p:nvSpPr>
-        <p:spPr>
-          <a:xfrm>
-            <a:off x="2615184" y="4169664"/>
-            <a:ext cx="1956816" cy="365760"/>
+              <a:rPr lang="en-US" sz="1300" b="1" dirty="0">
+                <a:solidFill>
+                  <a:srgbClr val="F2EEFA"/>
+                </a:solidFill>
+                <a:latin typeface="Malgun Gothic" pitchFamily="34" charset="0"/>
+                <a:ea typeface="Malgun Gothic" pitchFamily="34" charset="-122"/>
+                <a:cs typeface="Malgun Gothic" pitchFamily="34" charset="-120"/>
+              </a:rPr>
+              <a:t>드로잉</a:t>
+            </a:r>
+            <a:endParaRPr lang="en-US" sz="1300" dirty="0"/>
+          </a:p>
+        </p:txBody>
+      </p:sp>
+      <p:sp>
+        <p:nvSpPr>
+          <p:cNvPr id="27" name="Text 25"/>
+          <p:cNvSpPr/>
+          <p:nvPr/>
+        </p:nvSpPr>
+        <p:spPr>
+          <a:xfrm>
+            <a:off x="3566160" y="3822192"/>
+            <a:ext cx="347472" cy="566928"/>
           </a:xfrm>
           <a:prstGeom prst="rect">
             <a:avLst/>
@@ -4627,30 +4404,30 @@
               <a:buNone/>
             </a:pPr>
             <a:r>
-              <a:rPr lang="en-US" sz="1150" dirty="0">
-                <a:solidFill>
-                  <a:srgbClr val="9A92B8"/>
-                </a:solidFill>
-                <a:latin typeface="Malgun Gothic" pitchFamily="34" charset="0"/>
-                <a:ea typeface="Malgun Gothic" pitchFamily="34" charset="-122"/>
-                <a:cs typeface="Malgun Gothic" pitchFamily="34" charset="-120"/>
-              </a:rPr>
-              <a:t>Unity EditMode</a:t>
-            </a:r>
-            <a:endParaRPr lang="en-US" sz="1150" dirty="0"/>
-          </a:p>
-        </p:txBody>
-      </p:sp>
-      <p:sp>
-        <p:nvSpPr>
-          <p:cNvPr id="19" name="Shape 17"/>
-          <p:cNvSpPr/>
-          <p:nvPr/>
-        </p:nvSpPr>
-        <p:spPr>
-          <a:xfrm>
-            <a:off x="4773168" y="3456432"/>
-            <a:ext cx="1956816" cy="1207008"/>
+              <a:rPr lang="en-US" sz="1500" dirty="0">
+                <a:solidFill>
+                  <a:srgbClr val="F0B450"/>
+                </a:solidFill>
+                <a:latin typeface="Malgun Gothic" pitchFamily="34" charset="0"/>
+                <a:ea typeface="Malgun Gothic" pitchFamily="34" charset="-122"/>
+                <a:cs typeface="Malgun Gothic" pitchFamily="34" charset="-120"/>
+              </a:rPr>
+              <a:t>→</a:t>
+            </a:r>
+            <a:endParaRPr lang="en-US" sz="1500" dirty="0"/>
+          </a:p>
+        </p:txBody>
+      </p:sp>
+      <p:sp>
+        <p:nvSpPr>
+          <p:cNvPr id="28" name="Shape 26"/>
+          <p:cNvSpPr/>
+          <p:nvPr/>
+        </p:nvSpPr>
+        <p:spPr>
+          <a:xfrm>
+            <a:off x="3877056" y="3822192"/>
+            <a:ext cx="1417320" cy="566928"/>
           </a:xfrm>
           <a:prstGeom prst="rect">
             <a:avLst/>
@@ -4658,7 +4435,7 @@
           <a:solidFill>
             <a:srgbClr val="221C3A"/>
           </a:solidFill>
-          <a:ln w="12700">
+          <a:ln w="15240">
             <a:solidFill>
               <a:srgbClr val="37305A"/>
             </a:solidFill>
@@ -4668,14 +4445,14 @@
       </p:sp>
       <p:sp>
         <p:nvSpPr>
-          <p:cNvPr id="20" name="Text 18"/>
-          <p:cNvSpPr/>
-          <p:nvPr/>
-        </p:nvSpPr>
-        <p:spPr>
-          <a:xfrm>
-            <a:off x="4773168" y="3566160"/>
-            <a:ext cx="1956816" cy="566928"/>
+          <p:cNvPr id="29" name="Text 27"/>
+          <p:cNvSpPr/>
+          <p:nvPr/>
+        </p:nvSpPr>
+        <p:spPr>
+          <a:xfrm>
+            <a:off x="3877056" y="3822192"/>
+            <a:ext cx="1417320" cy="566928"/>
           </a:xfrm>
           <a:prstGeom prst="rect">
             <a:avLst/>
@@ -4691,30 +4468,30 @@
               <a:buNone/>
             </a:pPr>
             <a:r>
-              <a:rPr lang="en-US" sz="3000" b="1" dirty="0">
-                <a:solidFill>
-                  <a:srgbClr val="6FD98A"/>
-                </a:solidFill>
-                <a:latin typeface="Malgun Gothic" pitchFamily="34" charset="0"/>
-                <a:ea typeface="Malgun Gothic" pitchFamily="34" charset="-122"/>
-                <a:cs typeface="Malgun Gothic" pitchFamily="34" charset="-120"/>
-              </a:rPr>
-              <a:t>47</a:t>
-            </a:r>
-            <a:endParaRPr lang="en-US" sz="3000" dirty="0"/>
-          </a:p>
-        </p:txBody>
-      </p:sp>
-      <p:sp>
-        <p:nvSpPr>
-          <p:cNvPr id="21" name="Text 19"/>
-          <p:cNvSpPr/>
-          <p:nvPr/>
-        </p:nvSpPr>
-        <p:spPr>
-          <a:xfrm>
-            <a:off x="4773168" y="4169664"/>
-            <a:ext cx="1956816" cy="365760"/>
+              <a:rPr lang="en-US" sz="1300" b="1" dirty="0">
+                <a:solidFill>
+                  <a:srgbClr val="F2EEFA"/>
+                </a:solidFill>
+                <a:latin typeface="Malgun Gothic" pitchFamily="34" charset="0"/>
+                <a:ea typeface="Malgun Gothic" pitchFamily="34" charset="-122"/>
+                <a:cs typeface="Malgun Gothic" pitchFamily="34" charset="-120"/>
+              </a:rPr>
+              <a:t>인식 · 품질</a:t>
+            </a:r>
+            <a:endParaRPr lang="en-US" sz="1300" dirty="0"/>
+          </a:p>
+        </p:txBody>
+      </p:sp>
+      <p:sp>
+        <p:nvSpPr>
+          <p:cNvPr id="30" name="Text 28"/>
+          <p:cNvSpPr/>
+          <p:nvPr/>
+        </p:nvSpPr>
+        <p:spPr>
+          <a:xfrm>
+            <a:off x="5276088" y="3822192"/>
+            <a:ext cx="347472" cy="566928"/>
           </a:xfrm>
           <a:prstGeom prst="rect">
             <a:avLst/>
@@ -4730,30 +4507,30 @@
               <a:buNone/>
             </a:pPr>
             <a:r>
-              <a:rPr lang="en-US" sz="1150" dirty="0">
-                <a:solidFill>
-                  <a:srgbClr val="9A92B8"/>
-                </a:solidFill>
-                <a:latin typeface="Malgun Gothic" pitchFamily="34" charset="0"/>
-                <a:ea typeface="Malgun Gothic" pitchFamily="34" charset="-122"/>
-                <a:cs typeface="Malgun Gothic" pitchFamily="34" charset="-120"/>
-              </a:rPr>
-              <a:t>Unity PlayMode</a:t>
-            </a:r>
-            <a:endParaRPr lang="en-US" sz="1150" dirty="0"/>
-          </a:p>
-        </p:txBody>
-      </p:sp>
-      <p:sp>
-        <p:nvSpPr>
-          <p:cNvPr id="22" name="Shape 20"/>
-          <p:cNvSpPr/>
-          <p:nvPr/>
-        </p:nvSpPr>
-        <p:spPr>
-          <a:xfrm>
-            <a:off x="6931152" y="3456432"/>
-            <a:ext cx="1956816" cy="1207008"/>
+              <a:rPr lang="en-US" sz="1500" dirty="0">
+                <a:solidFill>
+                  <a:srgbClr val="F0B450"/>
+                </a:solidFill>
+                <a:latin typeface="Malgun Gothic" pitchFamily="34" charset="0"/>
+                <a:ea typeface="Malgun Gothic" pitchFamily="34" charset="-122"/>
+                <a:cs typeface="Malgun Gothic" pitchFamily="34" charset="-120"/>
+              </a:rPr>
+              <a:t>→</a:t>
+            </a:r>
+            <a:endParaRPr lang="en-US" sz="1500" dirty="0"/>
+          </a:p>
+        </p:txBody>
+      </p:sp>
+      <p:sp>
+        <p:nvSpPr>
+          <p:cNvPr id="31" name="Shape 29"/>
+          <p:cNvSpPr/>
+          <p:nvPr/>
+        </p:nvSpPr>
+        <p:spPr>
+          <a:xfrm>
+            <a:off x="5586984" y="3822192"/>
+            <a:ext cx="1417320" cy="566928"/>
           </a:xfrm>
           <a:prstGeom prst="rect">
             <a:avLst/>
@@ -4761,7 +4538,7 @@
           <a:solidFill>
             <a:srgbClr val="221C3A"/>
           </a:solidFill>
-          <a:ln w="12700">
+          <a:ln w="15240">
             <a:solidFill>
               <a:srgbClr val="37305A"/>
             </a:solidFill>
@@ -4771,14 +4548,14 @@
       </p:sp>
       <p:sp>
         <p:nvSpPr>
-          <p:cNvPr id="23" name="Text 21"/>
-          <p:cNvSpPr/>
-          <p:nvPr/>
-        </p:nvSpPr>
-        <p:spPr>
-          <a:xfrm>
-            <a:off x="6931152" y="3566160"/>
-            <a:ext cx="1956816" cy="566928"/>
+          <p:cNvPr id="32" name="Text 30"/>
+          <p:cNvSpPr/>
+          <p:nvPr/>
+        </p:nvSpPr>
+        <p:spPr>
+          <a:xfrm>
+            <a:off x="5586984" y="3822192"/>
+            <a:ext cx="1417320" cy="566928"/>
           </a:xfrm>
           <a:prstGeom prst="rect">
             <a:avLst/>
@@ -4794,30 +4571,30 @@
               <a:buNone/>
             </a:pPr>
             <a:r>
-              <a:rPr lang="en-US" sz="3000" b="1" dirty="0">
-                <a:solidFill>
-                  <a:srgbClr val="6FD98A"/>
-                </a:solidFill>
-                <a:latin typeface="Malgun Gothic" pitchFamily="34" charset="0"/>
-                <a:ea typeface="Malgun Gothic" pitchFamily="34" charset="-122"/>
-                <a:cs typeface="Malgun Gothic" pitchFamily="34" charset="-120"/>
-              </a:rPr>
-              <a:t>1줄</a:t>
-            </a:r>
-            <a:endParaRPr lang="en-US" sz="3000" dirty="0"/>
-          </a:p>
-        </p:txBody>
-      </p:sp>
-      <p:sp>
-        <p:nvSpPr>
-          <p:cNvPr id="24" name="Text 22"/>
-          <p:cNvSpPr/>
-          <p:nvPr/>
-        </p:nvSpPr>
-        <p:spPr>
-          <a:xfrm>
-            <a:off x="6931152" y="4169664"/>
-            <a:ext cx="1956816" cy="365760"/>
+              <a:rPr lang="en-US" sz="1300" b="1" dirty="0">
+                <a:solidFill>
+                  <a:srgbClr val="F2EEFA"/>
+                </a:solidFill>
+                <a:latin typeface="Malgun Gothic" pitchFamily="34" charset="0"/>
+                <a:ea typeface="Malgun Gothic" pitchFamily="34" charset="-122"/>
+                <a:cs typeface="Malgun Gothic" pitchFamily="34" charset="-120"/>
+              </a:rPr>
+              <a:t>세계 반응</a:t>
+            </a:r>
+            <a:endParaRPr lang="en-US" sz="1300" dirty="0"/>
+          </a:p>
+        </p:txBody>
+      </p:sp>
+      <p:sp>
+        <p:nvSpPr>
+          <p:cNvPr id="33" name="Text 31"/>
+          <p:cNvSpPr/>
+          <p:nvPr/>
+        </p:nvSpPr>
+        <p:spPr>
+          <a:xfrm>
+            <a:off x="6986016" y="3822192"/>
+            <a:ext cx="347472" cy="566928"/>
           </a:xfrm>
           <a:prstGeom prst="rect">
             <a:avLst/>
@@ -4833,17 +4610,81 @@
               <a:buNone/>
             </a:pPr>
             <a:r>
-              <a:rPr lang="en-US" sz="1150" dirty="0">
-                <a:solidFill>
-                  <a:srgbClr val="9A92B8"/>
-                </a:solidFill>
-                <a:latin typeface="Malgun Gothic" pitchFamily="34" charset="0"/>
-                <a:ea typeface="Malgun Gothic" pitchFamily="34" charset="-122"/>
-                <a:cs typeface="Malgun Gothic" pitchFamily="34" charset="-120"/>
-              </a:rPr>
-              <a:t>Windows 빌드 + smoke</a:t>
-            </a:r>
-            <a:endParaRPr lang="en-US" sz="1150" dirty="0"/>
+              <a:rPr lang="en-US" sz="1500" dirty="0">
+                <a:solidFill>
+                  <a:srgbClr val="F0B450"/>
+                </a:solidFill>
+                <a:latin typeface="Malgun Gothic" pitchFamily="34" charset="0"/>
+                <a:ea typeface="Malgun Gothic" pitchFamily="34" charset="-122"/>
+                <a:cs typeface="Malgun Gothic" pitchFamily="34" charset="-120"/>
+              </a:rPr>
+              <a:t>→</a:t>
+            </a:r>
+            <a:endParaRPr lang="en-US" sz="1500" dirty="0"/>
+          </a:p>
+        </p:txBody>
+      </p:sp>
+      <p:sp>
+        <p:nvSpPr>
+          <p:cNvPr id="34" name="Shape 32"/>
+          <p:cNvSpPr/>
+          <p:nvPr/>
+        </p:nvSpPr>
+        <p:spPr>
+          <a:xfrm>
+            <a:off x="7296912" y="3822192"/>
+            <a:ext cx="1417320" cy="566928"/>
+          </a:xfrm>
+          <a:prstGeom prst="rect">
+            <a:avLst/>
+          </a:prstGeom>
+          <a:solidFill>
+            <a:srgbClr val="2E2452"/>
+          </a:solidFill>
+          <a:ln w="15240">
+            <a:solidFill>
+              <a:srgbClr val="9D7BE8"/>
+            </a:solidFill>
+            <a:prstDash val="solid"/>
+          </a:ln>
+        </p:spPr>
+      </p:sp>
+      <p:sp>
+        <p:nvSpPr>
+          <p:cNvPr id="35" name="Text 33"/>
+          <p:cNvSpPr/>
+          <p:nvPr/>
+        </p:nvSpPr>
+        <p:spPr>
+          <a:xfrm>
+            <a:off x="7296912" y="3822192"/>
+            <a:ext cx="1417320" cy="566928"/>
+          </a:xfrm>
+          <a:prstGeom prst="rect">
+            <a:avLst/>
+          </a:prstGeom>
+          <a:noFill/>
+          <a:ln/>
+        </p:spPr>
+        <p:txBody>
+          <a:bodyPr wrap="square" rtlCol="0" anchor="ctr"/>
+          <a:lstStyle/>
+          <a:p>
+            <a:pPr algn="ctr" indent="0" marL="0">
+              <a:buNone/>
+            </a:pPr>
+            <a:r>
+              <a:rPr lang="en-US" sz="1300" b="1" dirty="0">
+                <a:solidFill>
+                  <a:srgbClr val="9D7BE8"/>
+                </a:solidFill>
+                <a:latin typeface="Malgun Gothic" pitchFamily="34" charset="0"/>
+                <a:ea typeface="Malgun Gothic" pitchFamily="34" charset="-122"/>
+                <a:cs typeface="Malgun Gothic" pitchFamily="34" charset="-120"/>
+              </a:rPr>
+              <a:t>조합 실험</a:t>
+            </a:r>
+            <a:endParaRPr lang="en-US" sz="1300" dirty="0"/>
           </a:p>
         </p:txBody>
       </p:sp>
@@ -4912,7 +4753,7 @@
                 <a:ea typeface="Malgun Gothic" pitchFamily="34" charset="-122"/>
                 <a:cs typeface="Malgun Gothic" pitchFamily="34" charset="-120"/>
               </a:rPr>
-              <a:t>검증</a:t>
+              <a:t>구현</a:t>
             </a:r>
             <a:endParaRPr lang="en-US" sz="1200" dirty="0"/>
           </a:p>
@@ -4951,7 +4792,7 @@
                 <a:ea typeface="Malgun Gothic" pitchFamily="34" charset="-122"/>
                 <a:cs typeface="Malgun Gothic" pitchFamily="34" charset="-120"/>
               </a:rPr>
-              <a:t>사용자 테스트 프로토콜</a:t>
+              <a:t>웹에서 검증하고, Unity로 이식</a:t>
             </a:r>
             <a:endParaRPr lang="en-US" sz="3000" dirty="0"/>
           </a:p>
@@ -5007,7 +4848,7 @@
         <p:spPr>
           <a:xfrm>
             <a:off x="457200" y="1371600"/>
-            <a:ext cx="4023360" cy="3291840"/>
+            <a:ext cx="4023360" cy="1417320"/>
           </a:xfrm>
           <a:prstGeom prst="rect">
             <a:avLst/>
@@ -5031,8 +4872,8 @@
         </p:nvSpPr>
         <p:spPr>
           <a:xfrm>
-            <a:off x="658368" y="1517904"/>
-            <a:ext cx="3657600" cy="292608"/>
+            <a:off x="658368" y="1499616"/>
+            <a:ext cx="3657600" cy="274320"/>
           </a:xfrm>
           <a:prstGeom prst="rect">
             <a:avLst/>
@@ -5056,7 +4897,7 @@
                 <a:ea typeface="Malgun Gothic" pitchFamily="34" charset="-122"/>
                 <a:cs typeface="Malgun Gothic" pitchFamily="34" charset="-120"/>
               </a:rPr>
-              <a:t>프로토콜 (RESEARCH_PROTOCOL)</a:t>
+              <a:t>Track 1 — Web Recognizer Lab</a:t>
             </a:r>
             <a:endParaRPr lang="en-US" sz="1350" dirty="0"/>
           </a:p>
@@ -5070,8 +4911,8 @@
         </p:nvSpPr>
         <p:spPr>
           <a:xfrm>
-            <a:off x="658368" y="1874520"/>
-            <a:ext cx="3657600" cy="2651760"/>
+            <a:off x="658368" y="1810512"/>
+            <a:ext cx="3657600" cy="868680"/>
           </a:xfrm>
           <a:prstGeom prst="rect">
             <a:avLst/>
@@ -5083,15 +4924,11 @@
           <a:bodyPr wrap="square" lIns="0" tIns="0" rIns="0" bIns="0" rtlCol="0" anchor="ctr"/>
           <a:lstStyle/>
           <a:p>
-            <a:pPr marL="342900" indent="-342900">
-              <a:spcAft>
-                <a:spcPts val="1000"/>
-              </a:spcAft>
-              <a:buSzPct val="100000"/>
-              <a:buChar char="•"/>
-            </a:pPr>
-            <a:r>
-              <a:rPr lang="en-US" sz="1250" dirty="0">
+            <a:pPr indent="0" marL="0">
+              <a:buNone/>
+            </a:pPr>
+            <a:r>
+              <a:rPr lang="en-US" sz="1200" dirty="0">
                 <a:solidFill>
                   <a:srgbClr val="F2EEFA"/>
                 </a:solidFill>
@@ -5099,20 +4936,16 @@
                 <a:ea typeface="Malgun Gothic" pitchFamily="34" charset="-122"/>
                 <a:cs typeface="Malgun Gothic" pitchFamily="34" charset="-120"/>
               </a:rPr>
-              <a:t>무설명 60분 완주 — 외부 테스터가 설명 없이 통과 엔딩(5/6)에 도달하는가</a:t>
-            </a:r>
-            <a:endParaRPr lang="en-US" sz="1250" dirty="0"/>
-          </a:p>
-          <a:p>
-            <a:pPr marL="342900" indent="-342900">
-              <a:spcAft>
-                <a:spcPts val="1000"/>
-              </a:spcAft>
-              <a:buSzPct val="100000"/>
-              <a:buChar char="•"/>
-            </a:pPr>
-            <a:r>
-              <a:rPr lang="en-US" sz="1250" dirty="0">
+              <a:t>빠른 인식 실험 · 대시보드 · 설문 수집</a:t>
+            </a:r>
+            <a:endParaRPr lang="en-US" sz="1200" dirty="0"/>
+          </a:p>
+          <a:p>
+            <a:pPr indent="0" marL="0">
+              <a:buNone/>
+            </a:pPr>
+            <a:r>
+              <a:rPr lang="en-US" sz="1200" dirty="0">
                 <a:solidFill>
                   <a:srgbClr val="F2EEFA"/>
                 </a:solidFill>
@@ -5120,64 +4953,61 @@
                 <a:ea typeface="Malgun Gothic" pitchFamily="34" charset="-122"/>
                 <a:cs typeface="Malgun Gothic" pitchFamily="34" charset="-120"/>
               </a:rPr>
-              <a:t>입력 버퍼 A/B: 0.6 / 0.8 / 1.0초</a:t>
-            </a:r>
-            <a:endParaRPr lang="en-US" sz="1250" dirty="0"/>
-          </a:p>
-          <a:p>
-            <a:pPr marL="342900" indent="-342900">
-              <a:spcAft>
-                <a:spcPts val="1000"/>
-              </a:spcAft>
-              <a:buSzPct val="100000"/>
-              <a:buChar char="•"/>
-            </a:pPr>
-            <a:r>
-              <a:rPr lang="en-US" sz="1250" dirty="0">
-                <a:solidFill>
-                  <a:srgbClr val="F2EEFA"/>
-                </a:solidFill>
-                <a:latin typeface="Malgun Gothic" pitchFamily="34" charset="0"/>
-                <a:ea typeface="Malgun Gothic" pitchFamily="34" charset="-122"/>
-                <a:cs typeface="Malgun Gothic" pitchFamily="34" charset="-120"/>
-              </a:rPr>
-              <a:t>attempts 로그 + 사후 설문 + 관찰표, 익명화 수집</a:t>
-            </a:r>
-            <a:endParaRPr lang="en-US" sz="1250" dirty="0"/>
-          </a:p>
-          <a:p>
-            <a:pPr marL="342900" indent="-342900">
-              <a:spcAft>
-                <a:spcPts val="1000"/>
-              </a:spcAft>
-              <a:buSzPct val="100000"/>
-              <a:buChar char="•"/>
-            </a:pPr>
-            <a:r>
-              <a:rPr lang="en-US" sz="1250" dirty="0">
-                <a:solidFill>
-                  <a:srgbClr val="F2EEFA"/>
-                </a:solidFill>
-                <a:latin typeface="Malgun Gothic" pitchFamily="34" charset="0"/>
-                <a:ea typeface="Malgun Gothic" pitchFamily="34" charset="-122"/>
-                <a:cs typeface="Malgun Gothic" pitchFamily="34" charset="-120"/>
-              </a:rPr>
-              <a:t>1차 결과로 오인식 상위 family 튜닝 → 2차에서 개선 폭 측정</a:t>
-            </a:r>
-            <a:endParaRPr lang="en-US" sz="1250" dirty="0"/>
-          </a:p>
-        </p:txBody>
-      </p:sp>
-      <p:sp>
-        <p:nvSpPr>
-          <p:cNvPr id="8" name="Shape 6"/>
-          <p:cNvSpPr/>
-          <p:nvPr/>
-        </p:nvSpPr>
-        <p:spPr>
-          <a:xfrm>
-            <a:off x="4663440" y="1371600"/>
-            <a:ext cx="4151376" cy="914400"/>
+              <a:t>stroke session → 특징 추출 → family + quality vector</a:t>
+            </a:r>
+            <a:endParaRPr lang="en-US" sz="1200" dirty="0"/>
+          </a:p>
+        </p:txBody>
+      </p:sp>
+      <p:sp>
+        <p:nvSpPr>
+          <p:cNvPr id="8" name="Text 6"/>
+          <p:cNvSpPr/>
+          <p:nvPr/>
+        </p:nvSpPr>
+        <p:spPr>
+          <a:xfrm>
+            <a:off x="4480560" y="1371600"/>
+            <a:ext cx="228600" cy="1417320"/>
+          </a:xfrm>
+          <a:prstGeom prst="rect">
+            <a:avLst/>
+          </a:prstGeom>
+          <a:noFill/>
+          <a:ln/>
+        </p:spPr>
+        <p:txBody>
+          <a:bodyPr wrap="square" rtlCol="0" anchor="ctr"/>
+          <a:lstStyle/>
+          <a:p>
+            <a:pPr algn="ctr" indent="0" marL="0">
+              <a:buNone/>
+            </a:pPr>
+            <a:r>
+              <a:rPr lang="en-US" sz="1800" dirty="0">
+                <a:solidFill>
+                  <a:srgbClr val="F0B450"/>
+                </a:solidFill>
+                <a:latin typeface="Malgun Gothic" pitchFamily="34" charset="0"/>
+                <a:ea typeface="Malgun Gothic" pitchFamily="34" charset="-122"/>
+                <a:cs typeface="Malgun Gothic" pitchFamily="34" charset="-120"/>
+              </a:rPr>
+              <a:t>→</a:t>
+            </a:r>
+            <a:endParaRPr lang="en-US" sz="1800" dirty="0"/>
+          </a:p>
+        </p:txBody>
+      </p:sp>
+      <p:sp>
+        <p:nvSpPr>
+          <p:cNvPr id="9" name="Shape 7"/>
+          <p:cNvSpPr/>
+          <p:nvPr/>
+        </p:nvSpPr>
+        <p:spPr>
+          <a:xfrm>
+            <a:off x="4709160" y="1371600"/>
+            <a:ext cx="4105656" cy="1417320"/>
           </a:xfrm>
           <a:prstGeom prst="rect">
             <a:avLst/>
@@ -5187,22 +5017,22 @@
           </a:solidFill>
           <a:ln w="12700">
             <a:solidFill>
-              <a:srgbClr val="F0B450"/>
+              <a:srgbClr val="37305A"/>
             </a:solidFill>
-            <a:prstDash val="dash"/>
+            <a:prstDash val="solid"/>
           </a:ln>
         </p:spPr>
       </p:sp>
       <p:sp>
         <p:nvSpPr>
-          <p:cNvPr id="9" name="Text 7"/>
-          <p:cNvSpPr/>
-          <p:nvPr/>
-        </p:nvSpPr>
-        <p:spPr>
-          <a:xfrm>
-            <a:off x="4773168" y="1371600"/>
-            <a:ext cx="3931920" cy="914400"/>
+          <p:cNvPr id="10" name="Text 8"/>
+          <p:cNvSpPr/>
+          <p:nvPr/>
+        </p:nvSpPr>
+        <p:spPr>
+          <a:xfrm>
+            <a:off x="4910328" y="1499616"/>
+            <a:ext cx="3749040" cy="274320"/>
           </a:xfrm>
           <a:prstGeom prst="rect">
             <a:avLst/>
@@ -5218,7 +5048,7 @@
               <a:buNone/>
             </a:pPr>
             <a:r>
-              <a:rPr lang="en-US" sz="1200" b="1" dirty="0">
+              <a:rPr lang="en-US" sz="1350" b="1" dirty="0">
                 <a:solidFill>
                   <a:srgbClr val="F0B450"/>
                 </a:solidFill>
@@ -5226,36 +5056,117 @@
                 <a:ea typeface="Malgun Gothic" pitchFamily="34" charset="-122"/>
                 <a:cs typeface="Malgun Gothic" pitchFamily="34" charset="-120"/>
               </a:rPr>
-              <a:t>(데이터) </a:t>
-            </a:r>
+              <a:t>Track 2 — Unity Playable (5층 시험장)</a:t>
+            </a:r>
+            <a:endParaRPr lang="en-US" sz="1350" dirty="0"/>
+          </a:p>
+        </p:txBody>
+      </p:sp>
+      <p:sp>
+        <p:nvSpPr>
+          <p:cNvPr id="11" name="Text 9"/>
+          <p:cNvSpPr/>
+          <p:nvPr/>
+        </p:nvSpPr>
+        <p:spPr>
+          <a:xfrm>
+            <a:off x="4910328" y="1810512"/>
+            <a:ext cx="3749040" cy="868680"/>
+          </a:xfrm>
+          <a:prstGeom prst="rect">
+            <a:avLst/>
+          </a:prstGeom>
+          <a:noFill/>
+          <a:ln/>
+        </p:spPr>
+        <p:txBody>
+          <a:bodyPr wrap="square" lIns="0" tIns="0" rIns="0" bIns="0" rtlCol="0" anchor="ctr"/>
+          <a:lstStyle/>
+          <a:p>
             <a:pPr indent="0" marL="0">
               <a:buNone/>
             </a:pPr>
             <a:r>
               <a:rPr lang="en-US" sz="1200" dirty="0">
                 <a:solidFill>
-                  <a:srgbClr val="9A92B8"/>
-                </a:solidFill>
-                <a:latin typeface="Malgun Gothic" pitchFamily="34" charset="0"/>
-                <a:ea typeface="Malgun Gothic" pitchFamily="34" charset="-122"/>
-                <a:cs typeface="Malgun Gothic" pitchFamily="34" charset="-120"/>
-              </a:rPr>
-              <a:t>1차 N=5 — 첫 시전까지 시간 / family별 첫 시도 성공률 / assist 도달률</a:t>
+                  <a:srgbClr val="F2EEFA"/>
+                </a:solidFill>
+                <a:latin typeface="Malgun Gothic" pitchFamily="34" charset="0"/>
+                <a:ea typeface="Malgun Gothic" pitchFamily="34" charset="-122"/>
+                <a:cs typeface="Malgun Gothic" pitchFamily="34" charset="-120"/>
+              </a:rPr>
+              <a:t>URP 2D 라이트 · 절차 SFX + 파일 우선 BGM 로더</a:t>
             </a:r>
             <a:endParaRPr lang="en-US" sz="1200" dirty="0"/>
           </a:p>
-        </p:txBody>
-      </p:sp>
-      <p:sp>
-        <p:nvSpPr>
-          <p:cNvPr id="10" name="Shape 8"/>
-          <p:cNvSpPr/>
-          <p:nvPr/>
-        </p:nvSpPr>
-        <p:spPr>
-          <a:xfrm>
-            <a:off x="4663440" y="2432304"/>
-            <a:ext cx="4151376" cy="914400"/>
+          <a:p>
+            <a:pPr indent="0" marL="0">
+              <a:buNone/>
+            </a:pPr>
+            <a:r>
+              <a:rPr lang="en-US" sz="1200" dirty="0">
+                <a:solidFill>
+                  <a:srgbClr val="F2EEFA"/>
+                </a:solidFill>
+                <a:latin typeface="Malgun Gothic" pitchFamily="34" charset="0"/>
+                <a:ea typeface="Malgun Gothic" pitchFamily="34" charset="-122"/>
+                <a:cs typeface="Malgun Gothic" pitchFamily="34" charset="-120"/>
+              </a:rPr>
+              <a:t>멘토 NPC · codex · 엔딩 분기 (5/6 통과 · 6/6 진엔딩)</a:t>
+            </a:r>
+            <a:endParaRPr lang="en-US" sz="1200" dirty="0"/>
+          </a:p>
+        </p:txBody>
+      </p:sp>
+      <p:sp>
+        <p:nvSpPr>
+          <p:cNvPr id="12" name="Text 10"/>
+          <p:cNvSpPr/>
+          <p:nvPr/>
+        </p:nvSpPr>
+        <p:spPr>
+          <a:xfrm>
+            <a:off x="457200" y="3063240"/>
+            <a:ext cx="8229600" cy="292608"/>
+          </a:xfrm>
+          <a:prstGeom prst="rect">
+            <a:avLst/>
+          </a:prstGeom>
+          <a:noFill/>
+          <a:ln/>
+        </p:spPr>
+        <p:txBody>
+          <a:bodyPr wrap="square" lIns="0" tIns="0" rIns="0" bIns="0" rtlCol="0" anchor="ctr"/>
+          <a:lstStyle/>
+          <a:p>
+            <a:pPr indent="0" marL="0">
+              <a:buNone/>
+            </a:pPr>
+            <a:r>
+              <a:rPr lang="en-US" sz="1300" b="1" dirty="0">
+                <a:solidFill>
+                  <a:srgbClr val="F2EEFA"/>
+                </a:solidFill>
+                <a:latin typeface="Malgun Gothic" pitchFamily="34" charset="0"/>
+                <a:ea typeface="Malgun Gothic" pitchFamily="34" charset="-122"/>
+                <a:cs typeface="Malgun Gothic" pitchFamily="34" charset="-120"/>
+              </a:rPr>
+              <a:t>검증 자동화 — 전부 자동으로 다시 돌릴 수 있다</a:t>
+            </a:r>
+            <a:endParaRPr lang="en-US" sz="1300" dirty="0"/>
+          </a:p>
+        </p:txBody>
+      </p:sp>
+      <p:sp>
+        <p:nvSpPr>
+          <p:cNvPr id="13" name="Shape 11"/>
+          <p:cNvSpPr/>
+          <p:nvPr/>
+        </p:nvSpPr>
+        <p:spPr>
+          <a:xfrm>
+            <a:off x="457200" y="3456432"/>
+            <a:ext cx="1956816" cy="1207008"/>
           </a:xfrm>
           <a:prstGeom prst="rect">
             <a:avLst/>
@@ -5265,52 +5176,77 @@
           </a:solidFill>
           <a:ln w="12700">
             <a:solidFill>
-              <a:srgbClr val="F0B450"/>
+              <a:srgbClr val="37305A"/>
             </a:solidFill>
-            <a:prstDash val="dash"/>
+            <a:prstDash val="solid"/>
           </a:ln>
         </p:spPr>
       </p:sp>
       <p:sp>
         <p:nvSpPr>
-          <p:cNvPr id="11" name="Text 9"/>
-          <p:cNvSpPr/>
-          <p:nvPr/>
-        </p:nvSpPr>
-        <p:spPr>
-          <a:xfrm>
-            <a:off x="4773168" y="2432304"/>
-            <a:ext cx="3931920" cy="914400"/>
-          </a:xfrm>
-          <a:prstGeom prst="rect">
-            <a:avLst/>
-          </a:prstGeom>
-          <a:noFill/>
-          <a:ln/>
-        </p:spPr>
-        <p:txBody>
-          <a:bodyPr wrap="square" lIns="0" tIns="0" rIns="0" bIns="0" rtlCol="0" anchor="ctr"/>
-          <a:lstStyle/>
-          <a:p>
-            <a:pPr indent="0" marL="0">
-              <a:buNone/>
-            </a:pPr>
-            <a:r>
-              <a:rPr lang="en-US" sz="1200" b="1" dirty="0">
-                <a:solidFill>
-                  <a:srgbClr val="F0B450"/>
-                </a:solidFill>
-                <a:latin typeface="Malgun Gothic" pitchFamily="34" charset="0"/>
-                <a:ea typeface="Malgun Gothic" pitchFamily="34" charset="-122"/>
-                <a:cs typeface="Malgun Gothic" pitchFamily="34" charset="-120"/>
-              </a:rPr>
-              <a:t>(데이터) </a:t>
-            </a:r>
-            <a:pPr indent="0" marL="0">
-              <a:buNone/>
-            </a:pPr>
-            <a:r>
-              <a:rPr lang="en-US" sz="1200" dirty="0">
+          <p:cNvPr id="14" name="Text 12"/>
+          <p:cNvSpPr/>
+          <p:nvPr/>
+        </p:nvSpPr>
+        <p:spPr>
+          <a:xfrm>
+            <a:off x="457200" y="3566160"/>
+            <a:ext cx="1956816" cy="566928"/>
+          </a:xfrm>
+          <a:prstGeom prst="rect">
+            <a:avLst/>
+          </a:prstGeom>
+          <a:noFill/>
+          <a:ln/>
+        </p:spPr>
+        <p:txBody>
+          <a:bodyPr wrap="square" rtlCol="0" anchor="ctr"/>
+          <a:lstStyle/>
+          <a:p>
+            <a:pPr algn="ctr" indent="0" marL="0">
+              <a:buNone/>
+            </a:pPr>
+            <a:r>
+              <a:rPr lang="en-US" sz="3000" b="1" dirty="0">
+                <a:solidFill>
+                  <a:srgbClr val="6FD98A"/>
+                </a:solidFill>
+                <a:latin typeface="Malgun Gothic" pitchFamily="34" charset="0"/>
+                <a:ea typeface="Malgun Gothic" pitchFamily="34" charset="-122"/>
+                <a:cs typeface="Malgun Gothic" pitchFamily="34" charset="-120"/>
+              </a:rPr>
+              <a:t>181</a:t>
+            </a:r>
+            <a:endParaRPr lang="en-US" sz="3000" dirty="0"/>
+          </a:p>
+        </p:txBody>
+      </p:sp>
+      <p:sp>
+        <p:nvSpPr>
+          <p:cNvPr id="15" name="Text 13"/>
+          <p:cNvSpPr/>
+          <p:nvPr/>
+        </p:nvSpPr>
+        <p:spPr>
+          <a:xfrm>
+            <a:off x="457200" y="4169664"/>
+            <a:ext cx="1956816" cy="365760"/>
+          </a:xfrm>
+          <a:prstGeom prst="rect">
+            <a:avLst/>
+          </a:prstGeom>
+          <a:noFill/>
+          <a:ln/>
+        </p:spPr>
+        <p:txBody>
+          <a:bodyPr wrap="square" rtlCol="0" anchor="ctr"/>
+          <a:lstStyle/>
+          <a:p>
+            <a:pPr algn="ctr" indent="0" marL="0">
+              <a:buNone/>
+            </a:pPr>
+            <a:r>
+              <a:rPr lang="en-US" sz="1150" dirty="0">
                 <a:solidFill>
                   <a:srgbClr val="9A92B8"/>
                 </a:solidFill>
@@ -5318,22 +5254,22 @@
                 <a:ea typeface="Malgun Gothic" pitchFamily="34" charset="-122"/>
                 <a:cs typeface="Malgun Gothic" pitchFamily="34" charset="-120"/>
               </a:rPr>
-              <a:t>2차 N=3~5 — 1차 대비 개선 폭 (인식 튜닝·체감 개선 반영 후)</a:t>
-            </a:r>
-            <a:endParaRPr lang="en-US" sz="1200" dirty="0"/>
-          </a:p>
-        </p:txBody>
-      </p:sp>
-      <p:sp>
-        <p:nvSpPr>
-          <p:cNvPr id="12" name="Shape 10"/>
-          <p:cNvSpPr/>
-          <p:nvPr/>
-        </p:nvSpPr>
-        <p:spPr>
-          <a:xfrm>
-            <a:off x="4663440" y="3493008"/>
-            <a:ext cx="4151376" cy="914400"/>
+              <a:t>Web 테스트 (Vitest)</a:t>
+            </a:r>
+            <a:endParaRPr lang="en-US" sz="1150" dirty="0"/>
+          </a:p>
+        </p:txBody>
+      </p:sp>
+      <p:sp>
+        <p:nvSpPr>
+          <p:cNvPr id="16" name="Shape 14"/>
+          <p:cNvSpPr/>
+          <p:nvPr/>
+        </p:nvSpPr>
+        <p:spPr>
+          <a:xfrm>
+            <a:off x="2615184" y="3456432"/>
+            <a:ext cx="1956816" cy="1207008"/>
           </a:xfrm>
           <a:prstGeom prst="rect">
             <a:avLst/>
@@ -5343,52 +5279,77 @@
           </a:solidFill>
           <a:ln w="12700">
             <a:solidFill>
-              <a:srgbClr val="F0B450"/>
+              <a:srgbClr val="37305A"/>
             </a:solidFill>
-            <a:prstDash val="dash"/>
+            <a:prstDash val="solid"/>
           </a:ln>
         </p:spPr>
       </p:sp>
       <p:sp>
         <p:nvSpPr>
-          <p:cNvPr id="13" name="Text 11"/>
-          <p:cNvSpPr/>
-          <p:nvPr/>
-        </p:nvSpPr>
-        <p:spPr>
-          <a:xfrm>
-            <a:off x="4773168" y="3493008"/>
-            <a:ext cx="3931920" cy="914400"/>
-          </a:xfrm>
-          <a:prstGeom prst="rect">
-            <a:avLst/>
-          </a:prstGeom>
-          <a:noFill/>
-          <a:ln/>
-        </p:spPr>
-        <p:txBody>
-          <a:bodyPr wrap="square" lIns="0" tIns="0" rIns="0" bIns="0" rtlCol="0" anchor="ctr"/>
-          <a:lstStyle/>
-          <a:p>
-            <a:pPr indent="0" marL="0">
-              <a:buNone/>
-            </a:pPr>
-            <a:r>
-              <a:rPr lang="en-US" sz="1200" b="1" dirty="0">
-                <a:solidFill>
-                  <a:srgbClr val="F0B450"/>
-                </a:solidFill>
-                <a:latin typeface="Malgun Gothic" pitchFamily="34" charset="0"/>
-                <a:ea typeface="Malgun Gothic" pitchFamily="34" charset="-122"/>
-                <a:cs typeface="Malgun Gothic" pitchFamily="34" charset="-120"/>
-              </a:rPr>
-              <a:t>(데이터) </a:t>
-            </a:r>
-            <a:pPr indent="0" marL="0">
-              <a:buNone/>
-            </a:pPr>
-            <a:r>
-              <a:rPr lang="en-US" sz="1200" dirty="0">
+          <p:cNvPr id="17" name="Text 15"/>
+          <p:cNvSpPr/>
+          <p:nvPr/>
+        </p:nvSpPr>
+        <p:spPr>
+          <a:xfrm>
+            <a:off x="2615184" y="3566160"/>
+            <a:ext cx="1956816" cy="566928"/>
+          </a:xfrm>
+          <a:prstGeom prst="rect">
+            <a:avLst/>
+          </a:prstGeom>
+          <a:noFill/>
+          <a:ln/>
+        </p:spPr>
+        <p:txBody>
+          <a:bodyPr wrap="square" rtlCol="0" anchor="ctr"/>
+          <a:lstStyle/>
+          <a:p>
+            <a:pPr algn="ctr" indent="0" marL="0">
+              <a:buNone/>
+            </a:pPr>
+            <a:r>
+              <a:rPr lang="en-US" sz="3000" b="1" dirty="0">
+                <a:solidFill>
+                  <a:srgbClr val="6FD98A"/>
+                </a:solidFill>
+                <a:latin typeface="Malgun Gothic" pitchFamily="34" charset="0"/>
+                <a:ea typeface="Malgun Gothic" pitchFamily="34" charset="-122"/>
+                <a:cs typeface="Malgun Gothic" pitchFamily="34" charset="-120"/>
+              </a:rPr>
+              <a:t>105</a:t>
+            </a:r>
+            <a:endParaRPr lang="en-US" sz="3000" dirty="0"/>
+          </a:p>
+        </p:txBody>
+      </p:sp>
+      <p:sp>
+        <p:nvSpPr>
+          <p:cNvPr id="18" name="Text 16"/>
+          <p:cNvSpPr/>
+          <p:nvPr/>
+        </p:nvSpPr>
+        <p:spPr>
+          <a:xfrm>
+            <a:off x="2615184" y="4169664"/>
+            <a:ext cx="1956816" cy="365760"/>
+          </a:xfrm>
+          <a:prstGeom prst="rect">
+            <a:avLst/>
+          </a:prstGeom>
+          <a:noFill/>
+          <a:ln/>
+        </p:spPr>
+        <p:txBody>
+          <a:bodyPr wrap="square" rtlCol="0" anchor="ctr"/>
+          <a:lstStyle/>
+          <a:p>
+            <a:pPr algn="ctr" indent="0" marL="0">
+              <a:buNone/>
+            </a:pPr>
+            <a:r>
+              <a:rPr lang="en-US" sz="1150" dirty="0">
                 <a:solidFill>
                   <a:srgbClr val="9A92B8"/>
                 </a:solidFill>
@@ -5396,9 +5357,215 @@
                 <a:ea typeface="Malgun Gothic" pitchFamily="34" charset="-122"/>
                 <a:cs typeface="Malgun Gothic" pitchFamily="34" charset="-120"/>
               </a:rPr>
-              <a:t>설문 — 공정성·몰입감 5점 척도 평균</a:t>
-            </a:r>
-            <a:endParaRPr lang="en-US" sz="1200" dirty="0"/>
+              <a:t>Unity EditMode</a:t>
+            </a:r>
+            <a:endParaRPr lang="en-US" sz="1150" dirty="0"/>
+          </a:p>
+        </p:txBody>
+      </p:sp>
+      <p:sp>
+        <p:nvSpPr>
+          <p:cNvPr id="19" name="Shape 17"/>
+          <p:cNvSpPr/>
+          <p:nvPr/>
+        </p:nvSpPr>
+        <p:spPr>
+          <a:xfrm>
+            <a:off x="4773168" y="3456432"/>
+            <a:ext cx="1956816" cy="1207008"/>
+          </a:xfrm>
+          <a:prstGeom prst="rect">
+            <a:avLst/>
+          </a:prstGeom>
+          <a:solidFill>
+            <a:srgbClr val="221C3A"/>
+          </a:solidFill>
+          <a:ln w="12700">
+            <a:solidFill>
+              <a:srgbClr val="37305A"/>
+            </a:solidFill>
+            <a:prstDash val="solid"/>
+          </a:ln>
+        </p:spPr>
+      </p:sp>
+      <p:sp>
+        <p:nvSpPr>
+          <p:cNvPr id="20" name="Text 18"/>
+          <p:cNvSpPr/>
+          <p:nvPr/>
+        </p:nvSpPr>
+        <p:spPr>
+          <a:xfrm>
+            <a:off x="4773168" y="3566160"/>
+            <a:ext cx="1956816" cy="566928"/>
+          </a:xfrm>
+          <a:prstGeom prst="rect">
+            <a:avLst/>
+          </a:prstGeom>
+          <a:noFill/>
+          <a:ln/>
+        </p:spPr>
+        <p:txBody>
+          <a:bodyPr wrap="square" rtlCol="0" anchor="ctr"/>
+          <a:lstStyle/>
+          <a:p>
+            <a:pPr algn="ctr" indent="0" marL="0">
+              <a:buNone/>
+            </a:pPr>
+            <a:r>
+              <a:rPr lang="en-US" sz="3000" b="1" dirty="0">
+                <a:solidFill>
+                  <a:srgbClr val="6FD98A"/>
+                </a:solidFill>
+                <a:latin typeface="Malgun Gothic" pitchFamily="34" charset="0"/>
+                <a:ea typeface="Malgun Gothic" pitchFamily="34" charset="-122"/>
+                <a:cs typeface="Malgun Gothic" pitchFamily="34" charset="-120"/>
+              </a:rPr>
+              <a:t>47</a:t>
+            </a:r>
+            <a:endParaRPr lang="en-US" sz="3000" dirty="0"/>
+          </a:p>
+        </p:txBody>
+      </p:sp>
+      <p:sp>
+        <p:nvSpPr>
+          <p:cNvPr id="21" name="Text 19"/>
+          <p:cNvSpPr/>
+          <p:nvPr/>
+        </p:nvSpPr>
+        <p:spPr>
+          <a:xfrm>
+            <a:off x="4773168" y="4169664"/>
+            <a:ext cx="1956816" cy="365760"/>
+          </a:xfrm>
+          <a:prstGeom prst="rect">
+            <a:avLst/>
+          </a:prstGeom>
+          <a:noFill/>
+          <a:ln/>
+        </p:spPr>
+        <p:txBody>
+          <a:bodyPr wrap="square" rtlCol="0" anchor="ctr"/>
+          <a:lstStyle/>
+          <a:p>
+            <a:pPr algn="ctr" indent="0" marL="0">
+              <a:buNone/>
+            </a:pPr>
+            <a:r>
+              <a:rPr lang="en-US" sz="1150" dirty="0">
+                <a:solidFill>
+                  <a:srgbClr val="9A92B8"/>
+                </a:solidFill>
+                <a:latin typeface="Malgun Gothic" pitchFamily="34" charset="0"/>
+                <a:ea typeface="Malgun Gothic" pitchFamily="34" charset="-122"/>
+                <a:cs typeface="Malgun Gothic" pitchFamily="34" charset="-120"/>
+              </a:rPr>
+              <a:t>Unity PlayMode</a:t>
+            </a:r>
+            <a:endParaRPr lang="en-US" sz="1150" dirty="0"/>
+          </a:p>
+        </p:txBody>
+      </p:sp>
+      <p:sp>
+        <p:nvSpPr>
+          <p:cNvPr id="22" name="Shape 20"/>
+          <p:cNvSpPr/>
+          <p:nvPr/>
+        </p:nvSpPr>
+        <p:spPr>
+          <a:xfrm>
+            <a:off x="6931152" y="3456432"/>
+            <a:ext cx="1956816" cy="1207008"/>
+          </a:xfrm>
+          <a:prstGeom prst="rect">
+            <a:avLst/>
+          </a:prstGeom>
+          <a:solidFill>
+            <a:srgbClr val="221C3A"/>
+          </a:solidFill>
+          <a:ln w="12700">
+            <a:solidFill>
+              <a:srgbClr val="37305A"/>
+            </a:solidFill>
+            <a:prstDash val="solid"/>
+          </a:ln>
+        </p:spPr>
+      </p:sp>
+      <p:sp>
+        <p:nvSpPr>
+          <p:cNvPr id="23" name="Text 21"/>
+          <p:cNvSpPr/>
+          <p:nvPr/>
+        </p:nvSpPr>
+        <p:spPr>
+          <a:xfrm>
+            <a:off x="6931152" y="3566160"/>
+            <a:ext cx="1956816" cy="566928"/>
+          </a:xfrm>
+          <a:prstGeom prst="rect">
+            <a:avLst/>
+          </a:prstGeom>
+          <a:noFill/>
+          <a:ln/>
+        </p:spPr>
+        <p:txBody>
+          <a:bodyPr wrap="square" rtlCol="0" anchor="ctr"/>
+          <a:lstStyle/>
+          <a:p>
+            <a:pPr algn="ctr" indent="0" marL="0">
+              <a:buNone/>
+            </a:pPr>
+            <a:r>
+              <a:rPr lang="en-US" sz="3000" b="1" dirty="0">
+                <a:solidFill>
+                  <a:srgbClr val="6FD98A"/>
+                </a:solidFill>
+                <a:latin typeface="Malgun Gothic" pitchFamily="34" charset="0"/>
+                <a:ea typeface="Malgun Gothic" pitchFamily="34" charset="-122"/>
+                <a:cs typeface="Malgun Gothic" pitchFamily="34" charset="-120"/>
+              </a:rPr>
+              <a:t>1줄</a:t>
+            </a:r>
+            <a:endParaRPr lang="en-US" sz="3000" dirty="0"/>
+          </a:p>
+        </p:txBody>
+      </p:sp>
+      <p:sp>
+        <p:nvSpPr>
+          <p:cNvPr id="24" name="Text 22"/>
+          <p:cNvSpPr/>
+          <p:nvPr/>
+        </p:nvSpPr>
+        <p:spPr>
+          <a:xfrm>
+            <a:off x="6931152" y="4169664"/>
+            <a:ext cx="1956816" cy="365760"/>
+          </a:xfrm>
+          <a:prstGeom prst="rect">
+            <a:avLst/>
+          </a:prstGeom>
+          <a:noFill/>
+          <a:ln/>
+        </p:spPr>
+        <p:txBody>
+          <a:bodyPr wrap="square" rtlCol="0" anchor="ctr"/>
+          <a:lstStyle/>
+          <a:p>
+            <a:pPr algn="ctr" indent="0" marL="0">
+              <a:buNone/>
+            </a:pPr>
+            <a:r>
+              <a:rPr lang="en-US" sz="1150" dirty="0">
+                <a:solidFill>
+                  <a:srgbClr val="9A92B8"/>
+                </a:solidFill>
+                <a:latin typeface="Malgun Gothic" pitchFamily="34" charset="0"/>
+                <a:ea typeface="Malgun Gothic" pitchFamily="34" charset="-122"/>
+                <a:cs typeface="Malgun Gothic" pitchFamily="34" charset="-120"/>
+              </a:rPr>
+              <a:t>Windows 빌드 + smoke</a:t>
+            </a:r>
+            <a:endParaRPr lang="en-US" sz="1150" dirty="0"/>
           </a:p>
         </p:txBody>
       </p:sp>
@@ -5467,7 +5634,7 @@
                 <a:ea typeface="Malgun Gothic" pitchFamily="34" charset="-122"/>
                 <a:cs typeface="Malgun Gothic" pitchFamily="34" charset="-120"/>
               </a:rPr>
-              <a:t>결과와 한계</a:t>
+              <a:t>검증</a:t>
             </a:r>
             <a:endParaRPr lang="en-US" sz="1200" dirty="0"/>
           </a:p>
@@ -5506,7 +5673,7 @@
                 <a:ea typeface="Malgun Gothic" pitchFamily="34" charset="-122"/>
                 <a:cs typeface="Malgun Gothic" pitchFamily="34" charset="-120"/>
               </a:rPr>
-              <a:t>“당신은 이런 마법사였습니다”</a:t>
+              <a:t>사용자 테스트 프로토콜</a:t>
             </a:r>
             <a:endParaRPr lang="en-US" sz="3000" dirty="0"/>
           </a:p>
@@ -5547,7 +5714,7 @@
                 <a:ea typeface="Malgun Gothic" pitchFamily="34" charset="-122"/>
                 <a:cs typeface="Malgun Gothic" pitchFamily="34" charset="-120"/>
               </a:rPr>
-              <a:t>1:00</a:t>
+              <a:t>1:30</a:t>
             </a:r>
             <a:endParaRPr lang="en-US" sz="1100" dirty="0"/>
           </a:p>
@@ -5562,7 +5729,7 @@
         <p:spPr>
           <a:xfrm>
             <a:off x="457200" y="1371600"/>
-            <a:ext cx="4023360" cy="1554480"/>
+            <a:ext cx="4023360" cy="3291840"/>
           </a:xfrm>
           <a:prstGeom prst="rect">
             <a:avLst/>
@@ -5611,7 +5778,7 @@
                 <a:ea typeface="Malgun Gothic" pitchFamily="34" charset="-122"/>
                 <a:cs typeface="Malgun Gothic" pitchFamily="34" charset="-120"/>
               </a:rPr>
-              <a:t>엔딩 리포트 — 플레이 스타일의 데이터화</a:t>
+              <a:t>프로토콜 (RESEARCH_PROTOCOL)</a:t>
             </a:r>
             <a:endParaRPr lang="en-US" sz="1350" dirty="0"/>
           </a:p>
@@ -5625,8 +5792,8 @@
         </p:nvSpPr>
         <p:spPr>
           <a:xfrm>
-            <a:off x="658368" y="1847088"/>
-            <a:ext cx="3657600" cy="914400"/>
+            <a:off x="658368" y="1874520"/>
+            <a:ext cx="3657600" cy="2651760"/>
           </a:xfrm>
           <a:prstGeom prst="rect">
             <a:avLst/>
@@ -5638,8 +5805,12 @@
           <a:bodyPr wrap="square" lIns="0" tIns="0" rIns="0" bIns="0" rtlCol="0" anchor="ctr"/>
           <a:lstStyle/>
           <a:p>
-            <a:pPr indent="0" marL="0">
-              <a:buNone/>
+            <a:pPr marL="342900" indent="-342900">
+              <a:spcAft>
+                <a:spcPts val="1000"/>
+              </a:spcAft>
+              <a:buSzPct val="100000"/>
+              <a:buChar char="•"/>
             </a:pPr>
             <a:r>
               <a:rPr lang="en-US" sz="1250" dirty="0">
@@ -5650,10 +5821,73 @@
                 <a:ea typeface="Malgun Gothic" pitchFamily="34" charset="-122"/>
                 <a:cs typeface="Malgun Gothic" pitchFamily="34" charset="-120"/>
               </a:rPr>
-              <a:t>가장 많이 쓴 base·overlay, 발견 수, 실패 회복 패턴이 한 장의 리포트로 요약된다</a:t>
+              <a:t>무설명 60분 완주 — 외부 테스터가 설명 없이 통과 엔딩(5/6)에 도달하는가</a:t>
             </a:r>
             <a:endParaRPr lang="en-US" sz="1250" dirty="0"/>
           </a:p>
+          <a:p>
+            <a:pPr marL="342900" indent="-342900">
+              <a:spcAft>
+                <a:spcPts val="1000"/>
+              </a:spcAft>
+              <a:buSzPct val="100000"/>
+              <a:buChar char="•"/>
+            </a:pPr>
+            <a:r>
+              <a:rPr lang="en-US" sz="1250" dirty="0">
+                <a:solidFill>
+                  <a:srgbClr val="F2EEFA"/>
+                </a:solidFill>
+                <a:latin typeface="Malgun Gothic" pitchFamily="34" charset="0"/>
+                <a:ea typeface="Malgun Gothic" pitchFamily="34" charset="-122"/>
+                <a:cs typeface="Malgun Gothic" pitchFamily="34" charset="-120"/>
+              </a:rPr>
+              <a:t>입력 버퍼 A/B: 0.6 / 0.8 / 1.0초</a:t>
+            </a:r>
+            <a:endParaRPr lang="en-US" sz="1250" dirty="0"/>
+          </a:p>
+          <a:p>
+            <a:pPr marL="342900" indent="-342900">
+              <a:spcAft>
+                <a:spcPts val="1000"/>
+              </a:spcAft>
+              <a:buSzPct val="100000"/>
+              <a:buChar char="•"/>
+            </a:pPr>
+            <a:r>
+              <a:rPr lang="en-US" sz="1250" dirty="0">
+                <a:solidFill>
+                  <a:srgbClr val="F2EEFA"/>
+                </a:solidFill>
+                <a:latin typeface="Malgun Gothic" pitchFamily="34" charset="0"/>
+                <a:ea typeface="Malgun Gothic" pitchFamily="34" charset="-122"/>
+                <a:cs typeface="Malgun Gothic" pitchFamily="34" charset="-120"/>
+              </a:rPr>
+              <a:t>attempts 로그 + 사후 설문 + 관찰표, 익명화 수집</a:t>
+            </a:r>
+            <a:endParaRPr lang="en-US" sz="1250" dirty="0"/>
+          </a:p>
+          <a:p>
+            <a:pPr marL="342900" indent="-342900">
+              <a:spcAft>
+                <a:spcPts val="1000"/>
+              </a:spcAft>
+              <a:buSzPct val="100000"/>
+              <a:buChar char="•"/>
+            </a:pPr>
+            <a:r>
+              <a:rPr lang="en-US" sz="1250" dirty="0">
+                <a:solidFill>
+                  <a:srgbClr val="F2EEFA"/>
+                </a:solidFill>
+                <a:latin typeface="Malgun Gothic" pitchFamily="34" charset="0"/>
+                <a:ea typeface="Malgun Gothic" pitchFamily="34" charset="-122"/>
+                <a:cs typeface="Malgun Gothic" pitchFamily="34" charset="-120"/>
+              </a:rPr>
+              <a:t>1차 결과로 오인식 상위 family 튜닝 → 2차에서 개선 폭 측정</a:t>
+            </a:r>
+            <a:endParaRPr lang="en-US" sz="1250" dirty="0"/>
+          </a:p>
         </p:txBody>
       </p:sp>
       <p:sp>
@@ -5664,8 +5898,8 @@
         </p:nvSpPr>
         <p:spPr>
           <a:xfrm>
-            <a:off x="457200" y="3108960"/>
-            <a:ext cx="4023360" cy="731520"/>
+            <a:off x="4663440" y="1371600"/>
+            <a:ext cx="4151376" cy="914400"/>
           </a:xfrm>
           <a:prstGeom prst="rect">
             <a:avLst/>
@@ -5689,8 +5923,8 @@
         </p:nvSpPr>
         <p:spPr>
           <a:xfrm>
-            <a:off x="566928" y="3108960"/>
-            <a:ext cx="3803904" cy="731520"/>
+            <a:off x="4773168" y="1371600"/>
+            <a:ext cx="3931920" cy="914400"/>
           </a:xfrm>
           <a:prstGeom prst="rect">
             <a:avLst/>
@@ -5728,7 +5962,7 @@
                 <a:ea typeface="Malgun Gothic" pitchFamily="34" charset="-122"/>
                 <a:cs typeface="Malgun Gothic" pitchFamily="34" charset="-120"/>
               </a:rPr>
-              <a:t>완주율 / 통과·진엔딩 비율 / 발견 수 분포</a:t>
+              <a:t>1차 N=5 — 첫 시전까지 시간 / family별 첫 시도 성공률 / assist 도달률</a:t>
             </a:r>
             <a:endParaRPr lang="en-US" sz="1200" dirty="0"/>
           </a:p>
@@ -5742,8 +5976,8 @@
         </p:nvSpPr>
         <p:spPr>
           <a:xfrm>
-            <a:off x="4663440" y="1371600"/>
-            <a:ext cx="4151376" cy="2468880"/>
+            <a:off x="4663440" y="2432304"/>
+            <a:ext cx="4151376" cy="914400"/>
           </a:xfrm>
           <a:prstGeom prst="rect">
             <a:avLst/>
@@ -5753,9 +5987,9 @@
           </a:solidFill>
           <a:ln w="12700">
             <a:solidFill>
-              <a:srgbClr val="37305A"/>
+              <a:srgbClr val="F0B450"/>
             </a:solidFill>
-            <a:prstDash val="solid"/>
+            <a:prstDash val="dash"/>
           </a:ln>
         </p:spPr>
       </p:sp>
@@ -5767,8 +6001,8 @@
         </p:nvSpPr>
         <p:spPr>
           <a:xfrm>
-            <a:off x="4864608" y="1517904"/>
-            <a:ext cx="3749040" cy="292608"/>
+            <a:off x="4773168" y="2432304"/>
+            <a:ext cx="3931920" cy="914400"/>
           </a:xfrm>
           <a:prstGeom prst="rect">
             <a:avLst/>
@@ -5784,30 +6018,69 @@
               <a:buNone/>
             </a:pPr>
             <a:r>
-              <a:rPr lang="en-US" sz="1350" b="1" dirty="0">
-                <a:solidFill>
-                  <a:srgbClr val="9D7BE8"/>
-                </a:solidFill>
-                <a:latin typeface="Malgun Gothic" pitchFamily="34" charset="0"/>
-                <a:ea typeface="Malgun Gothic" pitchFamily="34" charset="-122"/>
-                <a:cs typeface="Malgun Gothic" pitchFamily="34" charset="-120"/>
-              </a:rPr>
-              <a:t>한계</a:t>
-            </a:r>
-            <a:endParaRPr lang="en-US" sz="1350" dirty="0"/>
-          </a:p>
-        </p:txBody>
-      </p:sp>
-      <p:sp>
-        <p:nvSpPr>
-          <p:cNvPr id="12" name="Text 10"/>
-          <p:cNvSpPr/>
-          <p:nvPr/>
-        </p:nvSpPr>
-        <p:spPr>
-          <a:xfrm>
-            <a:off x="4864608" y="1874520"/>
-            <a:ext cx="3749040" cy="1280160"/>
+              <a:rPr lang="en-US" sz="1200" b="1" dirty="0">
+                <a:solidFill>
+                  <a:srgbClr val="F0B450"/>
+                </a:solidFill>
+                <a:latin typeface="Malgun Gothic" pitchFamily="34" charset="0"/>
+                <a:ea typeface="Malgun Gothic" pitchFamily="34" charset="-122"/>
+                <a:cs typeface="Malgun Gothic" pitchFamily="34" charset="-120"/>
+              </a:rPr>
+              <a:t>(데이터) </a:t>
+            </a:r>
+            <a:pPr indent="0" marL="0">
+              <a:buNone/>
+            </a:pPr>
+            <a:r>
+              <a:rPr lang="en-US" sz="1200" dirty="0">
+                <a:solidFill>
+                  <a:srgbClr val="9A92B8"/>
+                </a:solidFill>
+                <a:latin typeface="Malgun Gothic" pitchFamily="34" charset="0"/>
+                <a:ea typeface="Malgun Gothic" pitchFamily="34" charset="-122"/>
+                <a:cs typeface="Malgun Gothic" pitchFamily="34" charset="-120"/>
+              </a:rPr>
+              <a:t>2차 N=3~5 — 1차 대비 개선 폭 (인식 튜닝·체감 개선 반영 후)</a:t>
+            </a:r>
+            <a:endParaRPr lang="en-US" sz="1200" dirty="0"/>
+          </a:p>
+        </p:txBody>
+      </p:sp>
+      <p:sp>
+        <p:nvSpPr>
+          <p:cNvPr id="12" name="Shape 10"/>
+          <p:cNvSpPr/>
+          <p:nvPr/>
+        </p:nvSpPr>
+        <p:spPr>
+          <a:xfrm>
+            <a:off x="4663440" y="3493008"/>
+            <a:ext cx="4151376" cy="914400"/>
+          </a:xfrm>
+          <a:prstGeom prst="rect">
+            <a:avLst/>
+          </a:prstGeom>
+          <a:solidFill>
+            <a:srgbClr val="221C3A"/>
+          </a:solidFill>
+          <a:ln w="12700">
+            <a:solidFill>
+              <a:srgbClr val="F0B450"/>
+            </a:solidFill>
+            <a:prstDash val="dash"/>
+          </a:ln>
+        </p:spPr>
+      </p:sp>
+      <p:sp>
+        <p:nvSpPr>
+          <p:cNvPr id="13" name="Text 11"/>
+          <p:cNvSpPr/>
+          <p:nvPr/>
+        </p:nvSpPr>
+        <p:spPr>
+          <a:xfrm>
+            <a:off x="4773168" y="3493008"/>
+            <a:ext cx="3931920" cy="914400"/>
           </a:xfrm>
           <a:prstGeom prst="rect">
             <a:avLst/>
@@ -5819,96 +6092,11 @@
           <a:bodyPr wrap="square" lIns="0" tIns="0" rIns="0" bIns="0" rtlCol="0" anchor="ctr"/>
           <a:lstStyle/>
           <a:p>
-            <a:pPr marL="342900" indent="-342900">
-              <a:spcAft>
-                <a:spcPts val="800"/>
-              </a:spcAft>
-              <a:buSzPct val="100000"/>
-              <a:buChar char="•"/>
-            </a:pPr>
-            <a:r>
-              <a:rPr lang="en-US" sz="1250" dirty="0">
-                <a:solidFill>
-                  <a:srgbClr val="F2EEFA"/>
-                </a:solidFill>
-                <a:latin typeface="Malgun Gothic" pitchFamily="34" charset="0"/>
-                <a:ea typeface="Malgun Gothic" pitchFamily="34" charset="-122"/>
-                <a:cs typeface="Malgun Gothic" pitchFamily="34" charset="-120"/>
-              </a:rPr>
-              <a:t>인식 휴리스틱의 개인차 (필체 편향)</a:t>
-            </a:r>
-            <a:endParaRPr lang="en-US" sz="1250" dirty="0"/>
-          </a:p>
-          <a:p>
-            <a:pPr marL="342900" indent="-342900">
-              <a:spcAft>
-                <a:spcPts val="800"/>
-              </a:spcAft>
-              <a:buSzPct val="100000"/>
-              <a:buChar char="•"/>
-            </a:pPr>
-            <a:r>
-              <a:rPr lang="en-US" sz="1250" dirty="0">
-                <a:solidFill>
-                  <a:srgbClr val="F2EEFA"/>
-                </a:solidFill>
-                <a:latin typeface="Malgun Gothic" pitchFamily="34" charset="0"/>
-                <a:ea typeface="Malgun Gothic" pitchFamily="34" charset="-122"/>
-                <a:cs typeface="Malgun Gothic" pitchFamily="34" charset="-120"/>
-              </a:rPr>
-              <a:t>표본 크기 (N=5~10)</a:t>
-            </a:r>
-            <a:endParaRPr lang="en-US" sz="1250" dirty="0"/>
-          </a:p>
-          <a:p>
-            <a:pPr marL="342900" indent="-342900">
-              <a:spcAft>
-                <a:spcPts val="800"/>
-              </a:spcAft>
-              <a:buSzPct val="100000"/>
-              <a:buChar char="•"/>
-            </a:pPr>
-            <a:r>
-              <a:rPr lang="en-US" sz="1250" dirty="0">
-                <a:solidFill>
-                  <a:srgbClr val="F2EEFA"/>
-                </a:solidFill>
-                <a:latin typeface="Malgun Gothic" pitchFamily="34" charset="0"/>
-                <a:ea typeface="Malgun Gothic" pitchFamily="34" charset="-122"/>
-                <a:cs typeface="Malgun Gothic" pitchFamily="34" charset="-120"/>
-              </a:rPr>
-              <a:t>단일 세션 측정 — 학습 곡선 장기 추적 없음</a:t>
-            </a:r>
-            <a:endParaRPr lang="en-US" sz="1250" dirty="0"/>
-          </a:p>
-        </p:txBody>
-      </p:sp>
-      <p:sp>
-        <p:nvSpPr>
-          <p:cNvPr id="13" name="Text 11"/>
-          <p:cNvSpPr/>
-          <p:nvPr/>
-        </p:nvSpPr>
-        <p:spPr>
-          <a:xfrm>
-            <a:off x="4864608" y="3310128"/>
-            <a:ext cx="3749040" cy="365760"/>
-          </a:xfrm>
-          <a:prstGeom prst="rect">
-            <a:avLst/>
-          </a:prstGeom>
-          <a:noFill/>
-          <a:ln/>
-        </p:spPr>
-        <p:txBody>
-          <a:bodyPr wrap="square" lIns="0" tIns="0" rIns="0" bIns="0" rtlCol="0" anchor="ctr"/>
-          <a:lstStyle/>
-          <a:p>
-            <a:pPr indent="0" marL="0">
-              <a:buNone/>
-            </a:pPr>
-            <a:r>
-              <a:rPr lang="en-US" sz="1250" b="1" dirty="0">
+            <a:pPr indent="0" marL="0">
+              <a:buNone/>
+            </a:pPr>
+            <a:r>
+              <a:rPr lang="en-US" sz="1200" b="1" dirty="0">
                 <a:solidFill>
                   <a:srgbClr val="F0B450"/>
                 </a:solidFill>
@@ -5916,52 +6104,13 @@
                 <a:ea typeface="Malgun Gothic" pitchFamily="34" charset="-122"/>
                 <a:cs typeface="Malgun Gothic" pitchFamily="34" charset="-120"/>
               </a:rPr>
-              <a:t>다음  </a:t>
-            </a:r>
-            <a:pPr indent="0" marL="0">
-              <a:buNone/>
-            </a:pPr>
-            <a:r>
-              <a:rPr lang="en-US" sz="1250" dirty="0">
-                <a:solidFill>
-                  <a:srgbClr val="F2EEFA"/>
-                </a:solidFill>
-                <a:latin typeface="Malgun Gothic" pitchFamily="34" charset="0"/>
-                <a:ea typeface="Malgun Gothic" pitchFamily="34" charset="-122"/>
-                <a:cs typeface="Malgun Gothic" pitchFamily="34" charset="-120"/>
-              </a:rPr>
-              <a:t>user profile 보정 이식 · 외부 배포</a:t>
-            </a:r>
-            <a:endParaRPr lang="en-US" sz="1250" dirty="0"/>
-          </a:p>
-        </p:txBody>
-      </p:sp>
-      <p:sp>
-        <p:nvSpPr>
-          <p:cNvPr id="14" name="Text 12"/>
-          <p:cNvSpPr/>
-          <p:nvPr/>
-        </p:nvSpPr>
-        <p:spPr>
-          <a:xfrm>
-            <a:off x="457200" y="4526280"/>
-            <a:ext cx="8229600" cy="274320"/>
-          </a:xfrm>
-          <a:prstGeom prst="rect">
-            <a:avLst/>
-          </a:prstGeom>
-          <a:noFill/>
-          <a:ln/>
-        </p:spPr>
-        <p:txBody>
-          <a:bodyPr wrap="square" lIns="0" tIns="0" rIns="0" bIns="0" rtlCol="0" anchor="ctr"/>
-          <a:lstStyle/>
-          <a:p>
-            <a:pPr indent="0" marL="0">
-              <a:buNone/>
-            </a:pPr>
-            <a:r>
-              <a:rPr lang="en-US" sz="1050" i="1" dirty="0">
+              <a:t>(데이터) </a:t>
+            </a:r>
+            <a:pPr indent="0" marL="0">
+              <a:buNone/>
+            </a:pPr>
+            <a:r>
+              <a:rPr lang="en-US" sz="1200" dirty="0">
                 <a:solidFill>
                   <a:srgbClr val="9A92B8"/>
                 </a:solidFill>
@@ -5969,9 +6118,9 @@
                 <a:ea typeface="Malgun Gothic" pitchFamily="34" charset="-122"/>
                 <a:cs typeface="Malgun Gothic" pitchFamily="34" charset="-120"/>
               </a:rPr>
-              <a:t>발표 시 주의: 모든 (데이터) 칸은 플레이테스트 1·2차 결과로 채운 뒤 발표한다</a:t>
-            </a:r>
-            <a:endParaRPr lang="en-US" sz="1050" dirty="0"/>
+              <a:t>설문 — 공정성·몰입감 5점 척도 평균</a:t>
+            </a:r>
+            <a:endParaRPr lang="en-US" sz="1200" dirty="0"/>
           </a:p>
         </p:txBody>
       </p:sp>
@@ -5986,6 +6135,579 @@
 <file path=ppt/slides/slide7.xml><?xml version="1.0" encoding="utf-8"?>
 <p:sld xmlns:a="http://schemas.openxmlformats.org/drawingml/2006/main" xmlns:r="http://schemas.openxmlformats.org/officeDocument/2006/relationships" xmlns:p="http://schemas.openxmlformats.org/presentationml/2006/main">
   <p:cSld name="Slide 7">
+    <p:bg>
+      <p:bgPr>
+        <a:solidFill>
+          <a:srgbClr val="151226"/>
+        </a:solidFill>
+      </p:bgPr>
+    </p:bg>
+    <p:spTree>
+      <p:nvGrpSpPr>
+        <p:cNvPr id="1" name=""/>
+        <p:cNvGrpSpPr/>
+        <p:nvPr/>
+      </p:nvGrpSpPr>
+      <p:grpSpPr>
+        <a:xfrm>
+          <a:off x="0" y="0"/>
+          <a:ext cx="0" cy="0"/>
+          <a:chOff x="0" y="0"/>
+          <a:chExt cx="0" cy="0"/>
+        </a:xfrm>
+      </p:grpSpPr>
+      <p:sp>
+        <p:nvSpPr>
+          <p:cNvPr id="2" name="Text 0"/>
+          <p:cNvSpPr/>
+          <p:nvPr/>
+        </p:nvSpPr>
+        <p:spPr>
+          <a:xfrm>
+            <a:off x="457200" y="292608"/>
+            <a:ext cx="8229600" cy="274320"/>
+          </a:xfrm>
+          <a:prstGeom prst="rect">
+            <a:avLst/>
+          </a:prstGeom>
+          <a:noFill/>
+          <a:ln/>
+        </p:spPr>
+        <p:txBody>
+          <a:bodyPr wrap="square" lIns="0" tIns="0" rIns="0" bIns="0" rtlCol="0" anchor="ctr"/>
+          <a:lstStyle/>
+          <a:p>
+            <a:pPr indent="0" marL="0">
+              <a:buNone/>
+            </a:pPr>
+            <a:r>
+              <a:rPr lang="en-US" sz="1200" b="1" spc="300" kern="0" dirty="0">
+                <a:solidFill>
+                  <a:srgbClr val="F0B450"/>
+                </a:solidFill>
+                <a:latin typeface="Malgun Gothic" pitchFamily="34" charset="0"/>
+                <a:ea typeface="Malgun Gothic" pitchFamily="34" charset="-122"/>
+                <a:cs typeface="Malgun Gothic" pitchFamily="34" charset="-120"/>
+              </a:rPr>
+              <a:t>결과와 한계</a:t>
+            </a:r>
+            <a:endParaRPr lang="en-US" sz="1200" dirty="0"/>
+          </a:p>
+        </p:txBody>
+      </p:sp>
+      <p:sp>
+        <p:nvSpPr>
+          <p:cNvPr id="3" name="Text 1"/>
+          <p:cNvSpPr/>
+          <p:nvPr/>
+        </p:nvSpPr>
+        <p:spPr>
+          <a:xfrm>
+            <a:off x="457200" y="566928"/>
+            <a:ext cx="8229600" cy="640080"/>
+          </a:xfrm>
+          <a:prstGeom prst="rect">
+            <a:avLst/>
+          </a:prstGeom>
+          <a:noFill/>
+          <a:ln/>
+        </p:spPr>
+        <p:txBody>
+          <a:bodyPr wrap="square" lIns="0" tIns="0" rIns="0" bIns="0" rtlCol="0" anchor="ctr"/>
+          <a:lstStyle/>
+          <a:p>
+            <a:pPr indent="0" marL="0">
+              <a:buNone/>
+            </a:pPr>
+            <a:r>
+              <a:rPr lang="en-US" sz="3000" b="1" dirty="0">
+                <a:solidFill>
+                  <a:srgbClr val="F2EEFA"/>
+                </a:solidFill>
+                <a:latin typeface="Malgun Gothic" pitchFamily="34" charset="0"/>
+                <a:ea typeface="Malgun Gothic" pitchFamily="34" charset="-122"/>
+                <a:cs typeface="Malgun Gothic" pitchFamily="34" charset="-120"/>
+              </a:rPr>
+              <a:t>“당신은 이런 마법사였습니다”</a:t>
+            </a:r>
+            <a:endParaRPr lang="en-US" sz="3000" dirty="0"/>
+          </a:p>
+        </p:txBody>
+      </p:sp>
+      <p:sp>
+        <p:nvSpPr>
+          <p:cNvPr id="4" name="Text 2"/>
+          <p:cNvSpPr/>
+          <p:nvPr/>
+        </p:nvSpPr>
+        <p:spPr>
+          <a:xfrm>
+            <a:off x="7955280" y="310896"/>
+            <a:ext cx="777240" cy="274320"/>
+          </a:xfrm>
+          <a:prstGeom prst="rect">
+            <a:avLst/>
+          </a:prstGeom>
+          <a:solidFill>
+            <a:srgbClr val="F0B450"/>
+          </a:solidFill>
+          <a:ln/>
+        </p:spPr>
+        <p:txBody>
+          <a:bodyPr wrap="square" rtlCol="0" anchor="ctr"/>
+          <a:lstStyle/>
+          <a:p>
+            <a:pPr algn="ctr" indent="0" marL="0">
+              <a:buNone/>
+            </a:pPr>
+            <a:r>
+              <a:rPr lang="en-US" sz="1100" b="1" dirty="0">
+                <a:solidFill>
+                  <a:srgbClr val="151226"/>
+                </a:solidFill>
+                <a:latin typeface="Malgun Gothic" pitchFamily="34" charset="0"/>
+                <a:ea typeface="Malgun Gothic" pitchFamily="34" charset="-122"/>
+                <a:cs typeface="Malgun Gothic" pitchFamily="34" charset="-120"/>
+              </a:rPr>
+              <a:t>1:00</a:t>
+            </a:r>
+            <a:endParaRPr lang="en-US" sz="1100" dirty="0"/>
+          </a:p>
+        </p:txBody>
+      </p:sp>
+      <p:sp>
+        <p:nvSpPr>
+          <p:cNvPr id="5" name="Shape 3"/>
+          <p:cNvSpPr/>
+          <p:nvPr/>
+        </p:nvSpPr>
+        <p:spPr>
+          <a:xfrm>
+            <a:off x="457200" y="1371600"/>
+            <a:ext cx="4023360" cy="1554480"/>
+          </a:xfrm>
+          <a:prstGeom prst="rect">
+            <a:avLst/>
+          </a:prstGeom>
+          <a:solidFill>
+            <a:srgbClr val="221C3A"/>
+          </a:solidFill>
+          <a:ln w="12700">
+            <a:solidFill>
+              <a:srgbClr val="37305A"/>
+            </a:solidFill>
+            <a:prstDash val="solid"/>
+          </a:ln>
+        </p:spPr>
+      </p:sp>
+      <p:sp>
+        <p:nvSpPr>
+          <p:cNvPr id="6" name="Text 4"/>
+          <p:cNvSpPr/>
+          <p:nvPr/>
+        </p:nvSpPr>
+        <p:spPr>
+          <a:xfrm>
+            <a:off x="658368" y="1517904"/>
+            <a:ext cx="3657600" cy="292608"/>
+          </a:xfrm>
+          <a:prstGeom prst="rect">
+            <a:avLst/>
+          </a:prstGeom>
+          <a:noFill/>
+          <a:ln/>
+        </p:spPr>
+        <p:txBody>
+          <a:bodyPr wrap="square" lIns="0" tIns="0" rIns="0" bIns="0" rtlCol="0" anchor="ctr"/>
+          <a:lstStyle/>
+          <a:p>
+            <a:pPr indent="0" marL="0">
+              <a:buNone/>
+            </a:pPr>
+            <a:r>
+              <a:rPr lang="en-US" sz="1350" b="1" dirty="0">
+                <a:solidFill>
+                  <a:srgbClr val="F0B450"/>
+                </a:solidFill>
+                <a:latin typeface="Malgun Gothic" pitchFamily="34" charset="0"/>
+                <a:ea typeface="Malgun Gothic" pitchFamily="34" charset="-122"/>
+                <a:cs typeface="Malgun Gothic" pitchFamily="34" charset="-120"/>
+              </a:rPr>
+              <a:t>엔딩 리포트 — 플레이 스타일의 데이터화</a:t>
+            </a:r>
+            <a:endParaRPr lang="en-US" sz="1350" dirty="0"/>
+          </a:p>
+        </p:txBody>
+      </p:sp>
+      <p:sp>
+        <p:nvSpPr>
+          <p:cNvPr id="7" name="Text 5"/>
+          <p:cNvSpPr/>
+          <p:nvPr/>
+        </p:nvSpPr>
+        <p:spPr>
+          <a:xfrm>
+            <a:off x="658368" y="1847088"/>
+            <a:ext cx="3657600" cy="914400"/>
+          </a:xfrm>
+          <a:prstGeom prst="rect">
+            <a:avLst/>
+          </a:prstGeom>
+          <a:noFill/>
+          <a:ln/>
+        </p:spPr>
+        <p:txBody>
+          <a:bodyPr wrap="square" lIns="0" tIns="0" rIns="0" bIns="0" rtlCol="0" anchor="ctr"/>
+          <a:lstStyle/>
+          <a:p>
+            <a:pPr indent="0" marL="0">
+              <a:buNone/>
+            </a:pPr>
+            <a:r>
+              <a:rPr lang="en-US" sz="1250" dirty="0">
+                <a:solidFill>
+                  <a:srgbClr val="F2EEFA"/>
+                </a:solidFill>
+                <a:latin typeface="Malgun Gothic" pitchFamily="34" charset="0"/>
+                <a:ea typeface="Malgun Gothic" pitchFamily="34" charset="-122"/>
+                <a:cs typeface="Malgun Gothic" pitchFamily="34" charset="-120"/>
+              </a:rPr>
+              <a:t>가장 많이 쓴 base·overlay, 발견 수, 실패 회복 패턴이 한 장의 리포트로 요약된다</a:t>
+            </a:r>
+            <a:endParaRPr lang="en-US" sz="1250" dirty="0"/>
+          </a:p>
+        </p:txBody>
+      </p:sp>
+      <p:sp>
+        <p:nvSpPr>
+          <p:cNvPr id="8" name="Shape 6"/>
+          <p:cNvSpPr/>
+          <p:nvPr/>
+        </p:nvSpPr>
+        <p:spPr>
+          <a:xfrm>
+            <a:off x="457200" y="3108960"/>
+            <a:ext cx="4023360" cy="731520"/>
+          </a:xfrm>
+          <a:prstGeom prst="rect">
+            <a:avLst/>
+          </a:prstGeom>
+          <a:solidFill>
+            <a:srgbClr val="221C3A"/>
+          </a:solidFill>
+          <a:ln w="12700">
+            <a:solidFill>
+              <a:srgbClr val="F0B450"/>
+            </a:solidFill>
+            <a:prstDash val="dash"/>
+          </a:ln>
+        </p:spPr>
+      </p:sp>
+      <p:sp>
+        <p:nvSpPr>
+          <p:cNvPr id="9" name="Text 7"/>
+          <p:cNvSpPr/>
+          <p:nvPr/>
+        </p:nvSpPr>
+        <p:spPr>
+          <a:xfrm>
+            <a:off x="566928" y="3108960"/>
+            <a:ext cx="3803904" cy="731520"/>
+          </a:xfrm>
+          <a:prstGeom prst="rect">
+            <a:avLst/>
+          </a:prstGeom>
+          <a:noFill/>
+          <a:ln/>
+        </p:spPr>
+        <p:txBody>
+          <a:bodyPr wrap="square" lIns="0" tIns="0" rIns="0" bIns="0" rtlCol="0" anchor="ctr"/>
+          <a:lstStyle/>
+          <a:p>
+            <a:pPr indent="0" marL="0">
+              <a:buNone/>
+            </a:pPr>
+            <a:r>
+              <a:rPr lang="en-US" sz="1200" b="1" dirty="0">
+                <a:solidFill>
+                  <a:srgbClr val="F0B450"/>
+                </a:solidFill>
+                <a:latin typeface="Malgun Gothic" pitchFamily="34" charset="0"/>
+                <a:ea typeface="Malgun Gothic" pitchFamily="34" charset="-122"/>
+                <a:cs typeface="Malgun Gothic" pitchFamily="34" charset="-120"/>
+              </a:rPr>
+              <a:t>(데이터) </a:t>
+            </a:r>
+            <a:pPr indent="0" marL="0">
+              <a:buNone/>
+            </a:pPr>
+            <a:r>
+              <a:rPr lang="en-US" sz="1200" dirty="0">
+                <a:solidFill>
+                  <a:srgbClr val="9A92B8"/>
+                </a:solidFill>
+                <a:latin typeface="Malgun Gothic" pitchFamily="34" charset="0"/>
+                <a:ea typeface="Malgun Gothic" pitchFamily="34" charset="-122"/>
+                <a:cs typeface="Malgun Gothic" pitchFamily="34" charset="-120"/>
+              </a:rPr>
+              <a:t>완주율 / 통과·진엔딩 비율 / 발견 수 분포</a:t>
+            </a:r>
+            <a:endParaRPr lang="en-US" sz="1200" dirty="0"/>
+          </a:p>
+        </p:txBody>
+      </p:sp>
+      <p:sp>
+        <p:nvSpPr>
+          <p:cNvPr id="10" name="Shape 8"/>
+          <p:cNvSpPr/>
+          <p:nvPr/>
+        </p:nvSpPr>
+        <p:spPr>
+          <a:xfrm>
+            <a:off x="4663440" y="1371600"/>
+            <a:ext cx="4151376" cy="2468880"/>
+          </a:xfrm>
+          <a:prstGeom prst="rect">
+            <a:avLst/>
+          </a:prstGeom>
+          <a:solidFill>
+            <a:srgbClr val="221C3A"/>
+          </a:solidFill>
+          <a:ln w="12700">
+            <a:solidFill>
+              <a:srgbClr val="37305A"/>
+            </a:solidFill>
+            <a:prstDash val="solid"/>
+          </a:ln>
+        </p:spPr>
+      </p:sp>
+      <p:sp>
+        <p:nvSpPr>
+          <p:cNvPr id="11" name="Text 9"/>
+          <p:cNvSpPr/>
+          <p:nvPr/>
+        </p:nvSpPr>
+        <p:spPr>
+          <a:xfrm>
+            <a:off x="4864608" y="1517904"/>
+            <a:ext cx="3749040" cy="292608"/>
+          </a:xfrm>
+          <a:prstGeom prst="rect">
+            <a:avLst/>
+          </a:prstGeom>
+          <a:noFill/>
+          <a:ln/>
+        </p:spPr>
+        <p:txBody>
+          <a:bodyPr wrap="square" lIns="0" tIns="0" rIns="0" bIns="0" rtlCol="0" anchor="ctr"/>
+          <a:lstStyle/>
+          <a:p>
+            <a:pPr indent="0" marL="0">
+              <a:buNone/>
+            </a:pPr>
+            <a:r>
+              <a:rPr lang="en-US" sz="1350" b="1" dirty="0">
+                <a:solidFill>
+                  <a:srgbClr val="9D7BE8"/>
+                </a:solidFill>
+                <a:latin typeface="Malgun Gothic" pitchFamily="34" charset="0"/>
+                <a:ea typeface="Malgun Gothic" pitchFamily="34" charset="-122"/>
+                <a:cs typeface="Malgun Gothic" pitchFamily="34" charset="-120"/>
+              </a:rPr>
+              <a:t>한계</a:t>
+            </a:r>
+            <a:endParaRPr lang="en-US" sz="1350" dirty="0"/>
+          </a:p>
+        </p:txBody>
+      </p:sp>
+      <p:sp>
+        <p:nvSpPr>
+          <p:cNvPr id="12" name="Text 10"/>
+          <p:cNvSpPr/>
+          <p:nvPr/>
+        </p:nvSpPr>
+        <p:spPr>
+          <a:xfrm>
+            <a:off x="4864608" y="1874520"/>
+            <a:ext cx="3749040" cy="1280160"/>
+          </a:xfrm>
+          <a:prstGeom prst="rect">
+            <a:avLst/>
+          </a:prstGeom>
+          <a:noFill/>
+          <a:ln/>
+        </p:spPr>
+        <p:txBody>
+          <a:bodyPr wrap="square" lIns="0" tIns="0" rIns="0" bIns="0" rtlCol="0" anchor="ctr"/>
+          <a:lstStyle/>
+          <a:p>
+            <a:pPr marL="342900" indent="-342900">
+              <a:spcAft>
+                <a:spcPts val="800"/>
+              </a:spcAft>
+              <a:buSzPct val="100000"/>
+              <a:buChar char="•"/>
+            </a:pPr>
+            <a:r>
+              <a:rPr lang="en-US" sz="1250" dirty="0">
+                <a:solidFill>
+                  <a:srgbClr val="F2EEFA"/>
+                </a:solidFill>
+                <a:latin typeface="Malgun Gothic" pitchFamily="34" charset="0"/>
+                <a:ea typeface="Malgun Gothic" pitchFamily="34" charset="-122"/>
+                <a:cs typeface="Malgun Gothic" pitchFamily="34" charset="-120"/>
+              </a:rPr>
+              <a:t>인식 휴리스틱의 개인차 (필체 편향)</a:t>
+            </a:r>
+            <a:endParaRPr lang="en-US" sz="1250" dirty="0"/>
+          </a:p>
+          <a:p>
+            <a:pPr marL="342900" indent="-342900">
+              <a:spcAft>
+                <a:spcPts val="800"/>
+              </a:spcAft>
+              <a:buSzPct val="100000"/>
+              <a:buChar char="•"/>
+            </a:pPr>
+            <a:r>
+              <a:rPr lang="en-US" sz="1250" dirty="0">
+                <a:solidFill>
+                  <a:srgbClr val="F2EEFA"/>
+                </a:solidFill>
+                <a:latin typeface="Malgun Gothic" pitchFamily="34" charset="0"/>
+                <a:ea typeface="Malgun Gothic" pitchFamily="34" charset="-122"/>
+                <a:cs typeface="Malgun Gothic" pitchFamily="34" charset="-120"/>
+              </a:rPr>
+              <a:t>표본 크기 (N=5~10)</a:t>
+            </a:r>
+            <a:endParaRPr lang="en-US" sz="1250" dirty="0"/>
+          </a:p>
+          <a:p>
+            <a:pPr marL="342900" indent="-342900">
+              <a:spcAft>
+                <a:spcPts val="800"/>
+              </a:spcAft>
+              <a:buSzPct val="100000"/>
+              <a:buChar char="•"/>
+            </a:pPr>
+            <a:r>
+              <a:rPr lang="en-US" sz="1250" dirty="0">
+                <a:solidFill>
+                  <a:srgbClr val="F2EEFA"/>
+                </a:solidFill>
+                <a:latin typeface="Malgun Gothic" pitchFamily="34" charset="0"/>
+                <a:ea typeface="Malgun Gothic" pitchFamily="34" charset="-122"/>
+                <a:cs typeface="Malgun Gothic" pitchFamily="34" charset="-120"/>
+              </a:rPr>
+              <a:t>단일 세션 측정 — 학습 곡선 장기 추적 없음</a:t>
+            </a:r>
+            <a:endParaRPr lang="en-US" sz="1250" dirty="0"/>
+          </a:p>
+        </p:txBody>
+      </p:sp>
+      <p:sp>
+        <p:nvSpPr>
+          <p:cNvPr id="13" name="Text 11"/>
+          <p:cNvSpPr/>
+          <p:nvPr/>
+        </p:nvSpPr>
+        <p:spPr>
+          <a:xfrm>
+            <a:off x="4864608" y="3310128"/>
+            <a:ext cx="3749040" cy="365760"/>
+          </a:xfrm>
+          <a:prstGeom prst="rect">
+            <a:avLst/>
+          </a:prstGeom>
+          <a:noFill/>
+          <a:ln/>
+        </p:spPr>
+        <p:txBody>
+          <a:bodyPr wrap="square" lIns="0" tIns="0" rIns="0" bIns="0" rtlCol="0" anchor="ctr"/>
+          <a:lstStyle/>
+          <a:p>
+            <a:pPr indent="0" marL="0">
+              <a:buNone/>
+            </a:pPr>
+            <a:r>
+              <a:rPr lang="en-US" sz="1250" b="1" dirty="0">
+                <a:solidFill>
+                  <a:srgbClr val="F0B450"/>
+                </a:solidFill>
+                <a:latin typeface="Malgun Gothic" pitchFamily="34" charset="0"/>
+                <a:ea typeface="Malgun Gothic" pitchFamily="34" charset="-122"/>
+                <a:cs typeface="Malgun Gothic" pitchFamily="34" charset="-120"/>
+              </a:rPr>
+              <a:t>다음  </a:t>
+            </a:r>
+            <a:pPr indent="0" marL="0">
+              <a:buNone/>
+            </a:pPr>
+            <a:r>
+              <a:rPr lang="en-US" sz="1250" dirty="0">
+                <a:solidFill>
+                  <a:srgbClr val="F2EEFA"/>
+                </a:solidFill>
+                <a:latin typeface="Malgun Gothic" pitchFamily="34" charset="0"/>
+                <a:ea typeface="Malgun Gothic" pitchFamily="34" charset="-122"/>
+                <a:cs typeface="Malgun Gothic" pitchFamily="34" charset="-120"/>
+              </a:rPr>
+              <a:t>user profile 보정 이식 · 외부 배포</a:t>
+            </a:r>
+            <a:endParaRPr lang="en-US" sz="1250" dirty="0"/>
+          </a:p>
+        </p:txBody>
+      </p:sp>
+      <p:sp>
+        <p:nvSpPr>
+          <p:cNvPr id="14" name="Text 12"/>
+          <p:cNvSpPr/>
+          <p:nvPr/>
+        </p:nvSpPr>
+        <p:spPr>
+          <a:xfrm>
+            <a:off x="457200" y="4526280"/>
+            <a:ext cx="8229600" cy="274320"/>
+          </a:xfrm>
+          <a:prstGeom prst="rect">
+            <a:avLst/>
+          </a:prstGeom>
+          <a:noFill/>
+          <a:ln/>
+        </p:spPr>
+        <p:txBody>
+          <a:bodyPr wrap="square" lIns="0" tIns="0" rIns="0" bIns="0" rtlCol="0" anchor="ctr"/>
+          <a:lstStyle/>
+          <a:p>
+            <a:pPr indent="0" marL="0">
+              <a:buNone/>
+            </a:pPr>
+            <a:r>
+              <a:rPr lang="en-US" sz="1050" i="1" dirty="0">
+                <a:solidFill>
+                  <a:srgbClr val="9A92B8"/>
+                </a:solidFill>
+                <a:latin typeface="Malgun Gothic" pitchFamily="34" charset="0"/>
+                <a:ea typeface="Malgun Gothic" pitchFamily="34" charset="-122"/>
+                <a:cs typeface="Malgun Gothic" pitchFamily="34" charset="-120"/>
+              </a:rPr>
+              <a:t>발표 시 주의: 모든 (데이터) 칸은 플레이테스트 1·2차 결과로 채운 뒤 발표한다</a:t>
+            </a:r>
+            <a:endParaRPr lang="en-US" sz="1050" dirty="0"/>
+          </a:p>
+        </p:txBody>
+      </p:sp>
+    </p:spTree>
+  </p:cSld>
+  <p:clrMapOvr>
+    <a:masterClrMapping/>
+  </p:clrMapOvr>
+</p:sld>
+</file>
+
+<file path=ppt/slides/slide8.xml><?xml version="1.0" encoding="utf-8"?>
+<p:sld xmlns:a="http://schemas.openxmlformats.org/drawingml/2006/main" xmlns:r="http://schemas.openxmlformats.org/officeDocument/2006/relationships" xmlns:p="http://schemas.openxmlformats.org/presentationml/2006/main">
+  <p:cSld name="Slide 8">
     <p:bg>
       <p:bgPr>
         <a:solidFill>

</xml_diff>